<commit_message>
feat(p05): perkuat analogi membumi, kartu M3, dan dokumen kerangka kerja courseware
</commit_message>
<xml_diff>
--- a/03_slide_presentasi/PERTEMUAN_05_Material3_dan_Responsive_UI.pptx
+++ b/03_slide_presentasi/PERTEMUAN_05_Material3_dan_Responsive_UI.pptx
@@ -3695,7 +3695,7 @@
               </a:defRPr>
             </a:pPr>
             <a:r>
-              <a:t>OrientationBuilder: Merespons Rotasi Layar Smartphone</a:t>
+              <a:t>OrientationBuilder: Memutar Buku Sketsa (Tegak vs Miring)</a:t>
             </a:r>
           </a:p>
         </p:txBody>
@@ -3864,7 +3864,7 @@
               </a:defRPr>
             </a:pPr>
             <a:r>
-              <a:t>💡 KONSEP INTI &amp; CARA KERJA</a:t>
+              <a:t>💡 KONSEP INTI &amp; ANALOGI AWAM</a:t>
             </a:r>
           </a:p>
         </p:txBody>
@@ -3877,8 +3877,8 @@
         </p:nvSpPr>
         <p:spPr>
           <a:xfrm>
-            <a:off x="1005840" y="2176272"/>
-            <a:ext cx="4023360" cy="2926080"/>
+            <a:off x="1005840" y="2157984"/>
+            <a:ext cx="4023360" cy="2834640"/>
           </a:xfrm>
           <a:prstGeom prst="rect">
             <a:avLst/>
@@ -3893,9 +3893,9 @@
           <a:p>
             <a:pPr>
               <a:spcAft>
-                <a:spcPts val="800"/>
+                <a:spcPts val="600"/>
               </a:spcAft>
-              <a:defRPr sz="1050">
+              <a:defRPr sz="980">
                 <a:solidFill>
                   <a:srgbClr val="141414"/>
                 </a:solidFill>
@@ -3903,15 +3903,15 @@
               </a:defRPr>
             </a:pPr>
             <a:r>
-              <a:t>■  Ketika pengguna memiringkan ponselnya, tinggi layar berkurang drastis sementara lebar bertambah.</a:t>
+              <a:t>■  🎨 Analogi Buku Gambar: Saat buku tegak kita menggambar ke bawah; saat dimiringkan kita menggambar melebar ke samping.</a:t>
             </a:r>
           </a:p>
           <a:p>
             <a:pPr>
               <a:spcAft>
-                <a:spcPts val="800"/>
+                <a:spcPts val="600"/>
               </a:spcAft>
-              <a:defRPr sz="1050">
+              <a:defRPr sz="980">
                 <a:solidFill>
                   <a:srgbClr val="141414"/>
                 </a:solidFill>
@@ -3919,15 +3919,15 @@
               </a:defRPr>
             </a:pPr>
             <a:r>
-              <a:t>■  OrientationBuilder mendengarkan event rotasi dan membangun ulang UI secara reaktif.</a:t>
+              <a:t>■  🔄 Reaksi Rotasi Layar: 'OrientationBuilder' mendengarkan perputaran HP secara instan dan membangun ulang antarmuka yang cocok.</a:t>
             </a:r>
           </a:p>
           <a:p>
             <a:pPr>
               <a:spcAft>
-                <a:spcPts val="800"/>
+                <a:spcPts val="600"/>
               </a:spcAft>
-              <a:defRPr sz="1050">
+              <a:defRPr sz="980">
                 <a:solidFill>
                   <a:srgbClr val="141414"/>
                 </a:solidFill>
@@ -3935,15 +3935,15 @@
               </a:defRPr>
             </a:pPr>
             <a:r>
-              <a:t>■  Pola umum: Mengubah GridView dari 2 kolom (portrait) menjadi 4 kolom (landscape).</a:t>
+              <a:t>■  📊 Adaptasi Grid Cerdas: Ubah daftar dari 2 kolom (saat portrait) menjadi 4 kolom (saat landscape) agar ruang tidak terbuang sia-sia.</a:t>
             </a:r>
           </a:p>
           <a:p>
             <a:pPr>
               <a:spcAft>
-                <a:spcPts val="800"/>
+                <a:spcPts val="600"/>
               </a:spcAft>
-              <a:defRPr sz="1050">
+              <a:defRPr sz="980">
                 <a:solidFill>
                   <a:srgbClr val="141414"/>
                 </a:solidFill>
@@ -3951,7 +3951,7 @@
               </a:defRPr>
             </a:pPr>
             <a:r>
-              <a:t>■  Mencegah elemen formulir terpotong oleh keyboard saat ponsel dalam posisi miring.</a:t>
+              <a:t>■  ⌨️ Anti-Terpotong Keyboard: Pada posisi landscape, tinggi layar sangat terbatas, pastikan elemen formulir dapat di-scroll vertikal.</a:t>
             </a:r>
           </a:p>
         </p:txBody>
@@ -3964,8 +3964,8 @@
         </p:nvSpPr>
         <p:spPr>
           <a:xfrm>
-            <a:off x="960120" y="5074920"/>
-            <a:ext cx="4114800" cy="1005840"/>
+            <a:off x="960120" y="5047488"/>
+            <a:ext cx="4114800" cy="1051560"/>
           </a:xfrm>
           <a:prstGeom prst="rect">
             <a:avLst/>
@@ -4009,8 +4009,8 @@
         </p:nvSpPr>
         <p:spPr>
           <a:xfrm>
-            <a:off x="1005840" y="5102352"/>
-            <a:ext cx="4023360" cy="914400"/>
+            <a:off x="1005840" y="5074920"/>
+            <a:ext cx="4023360" cy="960120"/>
           </a:xfrm>
           <a:prstGeom prst="rect">
             <a:avLst/>
@@ -4024,7 +4024,7 @@
           <a:lstStyle/>
           <a:p>
             <a:pPr>
-              <a:defRPr sz="950" b="1">
+              <a:defRPr sz="919" b="1">
                 <a:solidFill>
                   <a:srgbClr val="000000"/>
                 </a:solidFill>
@@ -4032,11 +4032,11 @@
               </a:defRPr>
             </a:pPr>
             <a:r>
-              <a:t>💡 TIPS PRAKTIKUM:</a:t>
+              <a:t>💡 TIPS PRAKTIKUM &amp; PEDOMAN:</a:t>
             </a:r>
             <a:br/>
             <a:r>
-              <a:t>Uji rotasi layar di emulator atau Chrome dengan shortcut Ctrl + F11 / rotasi jendela!</a:t>
+              <a:t>Uji rotasi layar dengan shortcut Ctrl+F11 di emulator atau ubah rasio jendela Chrome!</a:t>
             </a:r>
           </a:p>
         </p:txBody>
@@ -4254,6 +4254,10 @@
             <a:br/>
             <a:r>
               <a:t>    return GridView.count(</a:t>
+            </a:r>
+            <a:br/>
+            <a:r>
+              <a:t>      // 2 kolom saat tegak, 4 kolom saat miring:</a:t>
             </a:r>
             <a:br/>
             <a:r>
@@ -4623,7 +4627,7 @@
               </a:defRPr>
             </a:pPr>
             <a:r>
-              <a:t>Navigasi Layar Lebar: NavigationBar vs NavigationRail</a:t>
+              <a:t>Navigasi Adaptif: Ergonomi Jangkauan Jempol Tangan Manusia</a:t>
             </a:r>
           </a:p>
         </p:txBody>
@@ -4792,7 +4796,7 @@
               </a:defRPr>
             </a:pPr>
             <a:r>
-              <a:t>💡 KONSEP INTI &amp; CARA KERJA</a:t>
+              <a:t>💡 KONSEP INTI &amp; ANALOGI AWAM</a:t>
             </a:r>
           </a:p>
         </p:txBody>
@@ -4805,8 +4809,8 @@
         </p:nvSpPr>
         <p:spPr>
           <a:xfrm>
-            <a:off x="1005840" y="2176272"/>
-            <a:ext cx="4023360" cy="2926080"/>
+            <a:off x="1005840" y="2157984"/>
+            <a:ext cx="4023360" cy="2834640"/>
           </a:xfrm>
           <a:prstGeom prst="rect">
             <a:avLst/>
@@ -4821,9 +4825,9 @@
           <a:p>
             <a:pPr>
               <a:spcAft>
-                <a:spcPts val="800"/>
+                <a:spcPts val="600"/>
               </a:spcAft>
-              <a:defRPr sz="1050">
+              <a:defRPr sz="980">
                 <a:solidFill>
                   <a:srgbClr val="141414"/>
                 </a:solidFill>
@@ -4831,15 +4835,15 @@
               </a:defRPr>
             </a:pPr>
             <a:r>
-              <a:t>■  Di ponsel: Jempol pengguna mudah menjangkau bilah bawah -&gt; Gunakan 'NavigationBar'.</a:t>
+              <a:t>■  👍 Analogi Jangkauan Jempol: Saat memegang HP satu tangan, jempol berada di bawah. Saat pegang tablet dua tangan di pinggir, jempol berada di sisi layar!</a:t>
             </a:r>
           </a:p>
           <a:p>
             <a:pPr>
               <a:spcAft>
-                <a:spcPts val="800"/>
+                <a:spcPts val="600"/>
               </a:spcAft>
-              <a:defRPr sz="1050">
+              <a:defRPr sz="980">
                 <a:solidFill>
                   <a:srgbClr val="141414"/>
                 </a:solidFill>
@@ -4847,15 +4851,15 @@
               </a:defRPr>
             </a:pPr>
             <a:r>
-              <a:t>■  Di tablet/desktop: Layar terlalu lebar untuk menu bawah -&gt; Pindahkan ke bilah samping kiri: 'NavigationRail'.</a:t>
+              <a:t>■  📱 Layar Ponsel (&lt;600dp): Gunakan 'NavigationBar' di dasar layar agar navigasi mudah dijangkau satu tangan pengguna.</a:t>
             </a:r>
           </a:p>
           <a:p>
             <a:pPr>
               <a:spcAft>
-                <a:spcPts val="800"/>
+                <a:spcPts val="600"/>
               </a:spcAft>
-              <a:defRPr sz="1050">
+              <a:defRPr sz="980">
                 <a:solidFill>
                   <a:srgbClr val="141414"/>
                 </a:solidFill>
@@ -4863,15 +4867,15 @@
               </a:defRPr>
             </a:pPr>
             <a:r>
-              <a:t>■  Kedua widget ini memiliki properti 'destinations' dan 'selectedIndex' yang serupa sehingga mudah digabungkan.</a:t>
+              <a:t>■  🖥️ Layar Tablet (&gt;=600dp): Pindahkan ke 'NavigationRail' di sisi kiri layar untuk menghemat ruang vertikal yang sangat berharga.</a:t>
             </a:r>
           </a:p>
           <a:p>
             <a:pPr>
               <a:spcAft>
-                <a:spcPts val="800"/>
+                <a:spcPts val="600"/>
               </a:spcAft>
-              <a:defRPr sz="1050">
+              <a:defRPr sz="980">
                 <a:solidFill>
                   <a:srgbClr val="141414"/>
                 </a:solidFill>
@@ -4879,7 +4883,7 @@
               </a:defRPr>
             </a:pPr>
             <a:r>
-              <a:t>■  Standar baku pengalaman pengguna profesional di tahun 2026.</a:t>
+              <a:t>■  🤝 Berbagi Halaman: Keduanya berbagi 'selectedIndex' dan daftar tujuan yang sama sehingga logika navigasi tidak perlu ditulis ulang.</a:t>
             </a:r>
           </a:p>
         </p:txBody>
@@ -4892,8 +4896,8 @@
         </p:nvSpPr>
         <p:spPr>
           <a:xfrm>
-            <a:off x="960120" y="5074920"/>
-            <a:ext cx="4114800" cy="1005840"/>
+            <a:off x="960120" y="5047488"/>
+            <a:ext cx="4114800" cy="1051560"/>
           </a:xfrm>
           <a:prstGeom prst="rect">
             <a:avLst/>
@@ -4937,8 +4941,8 @@
         </p:nvSpPr>
         <p:spPr>
           <a:xfrm>
-            <a:off x="1005840" y="5102352"/>
-            <a:ext cx="4023360" cy="914400"/>
+            <a:off x="1005840" y="5074920"/>
+            <a:ext cx="4023360" cy="960120"/>
           </a:xfrm>
           <a:prstGeom prst="rect">
             <a:avLst/>
@@ -4952,7 +4956,7 @@
           <a:lstStyle/>
           <a:p>
             <a:pPr>
-              <a:defRPr sz="950" b="1">
+              <a:defRPr sz="919" b="1">
                 <a:solidFill>
                   <a:srgbClr val="000000"/>
                 </a:solidFill>
@@ -4960,11 +4964,11 @@
               </a:defRPr>
             </a:pPr>
             <a:r>
-              <a:t>💡 TIPS PRAKTIKUM:</a:t>
+              <a:t>💡 TIPS PRAKTIKUM &amp; PEDOMAN:</a:t>
             </a:r>
             <a:br/>
             <a:r>
-              <a:t>NavigationRail di samping menghemat ruang vertikal tablet yang sangat berharga!</a:t>
+              <a:t>NavigationRail di sisi kiri membuat antarmuka tablet terlihat elegan dan berkelas profesional!</a:t>
             </a:r>
           </a:p>
         </p:txBody>
@@ -5185,7 +5189,7 @@
             </a:r>
             <a:br/>
             <a:r>
-              <a:t>        NavigationRail(</a:t>
+              <a:t>        NavigationRail( // Samping kiri di tablet</a:t>
             </a:r>
             <a:br/>
             <a:r>
@@ -5213,7 +5217,7 @@
             </a:r>
             <a:br/>
             <a:r>
-              <a:t>  bottomNavigationBar: isTablet ? null : NavigationBar(...),</a:t>
+              <a:t>  bottomNavigationBar: isTablet ? null : NavigationBar(...), // Bawah di HP</a:t>
             </a:r>
             <a:br/>
             <a:r>
@@ -5567,7 +5571,7 @@
               </a:defRPr>
             </a:pPr>
             <a:r>
-              <a:t>Grid Responsif: Menyesuaikan Kolom Otomatis</a:t>
+              <a:t>Grid Responsif Dinamis: Rak Pajangan Toko Fleksibel</a:t>
             </a:r>
           </a:p>
         </p:txBody>
@@ -5736,7 +5740,7 @@
               </a:defRPr>
             </a:pPr>
             <a:r>
-              <a:t>💡 KONSEP INTI &amp; CARA KERJA</a:t>
+              <a:t>💡 KONSEP INTI &amp; ANALOGI AWAM</a:t>
             </a:r>
           </a:p>
         </p:txBody>
@@ -5749,8 +5753,8 @@
         </p:nvSpPr>
         <p:spPr>
           <a:xfrm>
-            <a:off x="1005840" y="2176272"/>
-            <a:ext cx="4023360" cy="2926080"/>
+            <a:off x="1005840" y="2157984"/>
+            <a:ext cx="4023360" cy="2834640"/>
           </a:xfrm>
           <a:prstGeom prst="rect">
             <a:avLst/>
@@ -5765,9 +5769,9 @@
           <a:p>
             <a:pPr>
               <a:spcAft>
-                <a:spcPts val="800"/>
+                <a:spcPts val="600"/>
               </a:spcAft>
-              <a:defRPr sz="1050">
+              <a:defRPr sz="980">
                 <a:solidFill>
                   <a:srgbClr val="141414"/>
                 </a:solidFill>
@@ -5775,15 +5779,15 @@
               </a:defRPr>
             </a:pPr>
             <a:r>
-              <a:t>■  Jangan mematok jumlah kolom grid secara kaku (misal: crossAxisCount: 2). Di tablet, kartu akan melar aneh!</a:t>
+              <a:t>■  🏪 Analogi Rak Toko: Rak sempit memuat 2 produk, rak lebar memuat 4 hingga 6 produk tanpa membuat kemasan produk melar gepeng.</a:t>
             </a:r>
           </a:p>
           <a:p>
             <a:pPr>
               <a:spcAft>
-                <a:spcPts val="800"/>
+                <a:spcPts val="600"/>
               </a:spcAft>
-              <a:defRPr sz="1050">
+              <a:defRPr sz="980">
                 <a:solidFill>
                   <a:srgbClr val="141414"/>
                 </a:solidFill>
@@ -5791,15 +5795,15 @@
               </a:defRPr>
             </a:pPr>
             <a:r>
-              <a:t>■  Gunakan rumus pembagi atau fungsi helper berdasarkan lebar ruang: width &lt; 600 (1 kolom), &lt; 900 (2 kolom), &gt; 900 (3 kolom).</a:t>
+              <a:t>■  🚫 Kesalahan Pemula: Menulis 'crossAxisCount: 2' permanen. Di tablet layar lebar, kartu produk akan melar aneh seperti kardus kulkas!</a:t>
             </a:r>
           </a:p>
           <a:p>
             <a:pPr>
               <a:spcAft>
-                <a:spcPts val="800"/>
+                <a:spcPts val="600"/>
               </a:spcAft>
-              <a:defRPr sz="1050">
+              <a:defRPr sz="980">
                 <a:solidFill>
                   <a:srgbClr val="141414"/>
                 </a:solidFill>
@@ -5807,15 +5811,15 @@
               </a:defRPr>
             </a:pPr>
             <a:r>
-              <a:t>■  Atau gunakan: 'SliverGridDelegateWithMaxCrossAxisExtent' dengan maxCrossAxisExtent: 250.</a:t>
+              <a:t>■  🧮 Solusi Rumus Adaptif: Tentukan jumlah kolom lewat rumus lebar: lebar &lt;600 (1-2 kolom), &lt;900 (3 kolom), &gt;900 (4-6 kolom).</a:t>
             </a:r>
           </a:p>
           <a:p>
             <a:pPr>
               <a:spcAft>
-                <a:spcPts val="800"/>
+                <a:spcPts val="600"/>
               </a:spcAft>
-              <a:defRPr sz="1050">
+              <a:defRPr sz="980">
                 <a:solidFill>
                   <a:srgbClr val="141414"/>
                 </a:solidFill>
@@ -5823,7 +5827,7 @@
               </a:defRPr>
             </a:pPr>
             <a:r>
-              <a:t>■  Hasilnya: Berapa pun lebar layar yang ditarik pengguna, ukuran kartu tetap proporsional.</a:t>
+              <a:t>■  ✨ Opsi Otomatis: Atau gunakan 'SliverGridDelegateWithMaxCrossAxisExtent(maxCrossAxisExtent: 220)'—Flutter yang menghitungkan kolomnya!</a:t>
             </a:r>
           </a:p>
         </p:txBody>
@@ -5836,8 +5840,8 @@
         </p:nvSpPr>
         <p:spPr>
           <a:xfrm>
-            <a:off x="960120" y="5074920"/>
-            <a:ext cx="4114800" cy="1005840"/>
+            <a:off x="960120" y="5047488"/>
+            <a:ext cx="4114800" cy="1051560"/>
           </a:xfrm>
           <a:prstGeom prst="rect">
             <a:avLst/>
@@ -5881,8 +5885,8 @@
         </p:nvSpPr>
         <p:spPr>
           <a:xfrm>
-            <a:off x="1005840" y="5102352"/>
-            <a:ext cx="4023360" cy="914400"/>
+            <a:off x="1005840" y="5074920"/>
+            <a:ext cx="4023360" cy="960120"/>
           </a:xfrm>
           <a:prstGeom prst="rect">
             <a:avLst/>
@@ -5896,7 +5900,7 @@
           <a:lstStyle/>
           <a:p>
             <a:pPr>
-              <a:defRPr sz="950" b="1">
+              <a:defRPr sz="919" b="1">
                 <a:solidFill>
                   <a:srgbClr val="000000"/>
                 </a:solidFill>
@@ -5904,11 +5908,11 @@
               </a:defRPr>
             </a:pPr>
             <a:r>
-              <a:t>💡 TIPS PRAKTIKUM:</a:t>
+              <a:t>💡 TIPS PRAKTIKUM &amp; PEDOMAN:</a:t>
             </a:r>
             <a:br/>
             <a:r>
-              <a:t>Uji grid Anda pada resolusi tablet agar kartu tidak terlihat gepeng atau meregang.</a:t>
+              <a:t>Gunakan maxCrossAxisExtent jika Anda ingin ukuran kartu selalu konsisten di segala resolusi layar!</a:t>
             </a:r>
           </a:p>
         </p:txBody>
@@ -6117,15 +6121,15 @@
             </a:r>
             <a:br/>
             <a:r>
-              <a:t>  if (width &lt; 600) return 1; // Ponsel</a:t>
+              <a:t>  if (width &lt; 600) return 1; // Ponsel (1 kolom)</a:t>
             </a:r>
             <a:br/>
             <a:r>
-              <a:t>  if (width &lt; 900) return 2; // Tablet</a:t>
+              <a:t>  if (width &lt; 900) return 2; // Tablet (2 kolom)</a:t>
             </a:r>
             <a:br/>
             <a:r>
-              <a:t>  return 3;                  // Desktop</a:t>
+              <a:t>  return 3;                  // Desktop (3 kolom)</a:t>
             </a:r>
             <a:br/>
             <a:r>
@@ -6504,7 +6508,7 @@
               </a:defRPr>
             </a:pPr>
             <a:r>
-              <a:t>Pola Master-Detail: Tumpukan HP vs Split Pane Tablet</a:t>
+              <a:t>Pola Master-Detail: WhatsApp di HP vs WhatsApp Web di Komputer</a:t>
             </a:r>
           </a:p>
         </p:txBody>
@@ -6673,7 +6677,7 @@
               </a:defRPr>
             </a:pPr>
             <a:r>
-              <a:t>💡 KONSEP INTI &amp; CARA KERJA</a:t>
+              <a:t>💡 KONSEP INTI &amp; ANALOGI AWAM</a:t>
             </a:r>
           </a:p>
         </p:txBody>
@@ -6686,8 +6690,8 @@
         </p:nvSpPr>
         <p:spPr>
           <a:xfrm>
-            <a:off x="1005840" y="2176272"/>
-            <a:ext cx="4023360" cy="2926080"/>
+            <a:off x="1005840" y="2157984"/>
+            <a:ext cx="4023360" cy="2834640"/>
           </a:xfrm>
           <a:prstGeom prst="rect">
             <a:avLst/>
@@ -6702,9 +6706,9 @@
           <a:p>
             <a:pPr>
               <a:spcAft>
-                <a:spcPts val="800"/>
+                <a:spcPts val="600"/>
               </a:spcAft>
-              <a:defRPr sz="1050">
+              <a:defRPr sz="980">
                 <a:solidFill>
                   <a:srgbClr val="141414"/>
                 </a:solidFill>
@@ -6712,15 +6716,15 @@
               </a:defRPr>
             </a:pPr>
             <a:r>
-              <a:t>■  Di ponsel: Pengguna mengetuk item daftar -&gt; Berpindah ke layar detail baru (Navigator.push).</a:t>
+              <a:t>■  💬 Analogi WhatsApp &amp; Gmail: Di HP, kita ketuk kontak -&gt; tumpukan layar ganti ke chat -&gt; tekan tombol Back untuk kembali.</a:t>
             </a:r>
           </a:p>
           <a:p>
             <a:pPr>
               <a:spcAft>
-                <a:spcPts val="800"/>
+                <a:spcPts val="600"/>
               </a:spcAft>
-              <a:defRPr sz="1050">
+              <a:defRPr sz="980">
                 <a:solidFill>
                   <a:srgbClr val="141414"/>
                 </a:solidFill>
@@ -6728,15 +6732,15 @@
               </a:defRPr>
             </a:pPr>
             <a:r>
-              <a:t>■  Di tablet: Daftar (Master) dan rincian (Detail) ditampilkan berdampingan dalam satu layar (Split Pane).</a:t>
+              <a:t>■  💻 Di Laptop/Tablet: Daftar kontak (Master) di sisi kiri dan obrolan pesan (Detail) di sisi kanan tampil berdampingan dalam satu layar.</a:t>
             </a:r>
           </a:p>
           <a:p>
             <a:pPr>
               <a:spcAft>
-                <a:spcPts val="800"/>
+                <a:spcPts val="600"/>
               </a:spcAft>
-              <a:defRPr sz="1050">
+              <a:defRPr sz="980">
                 <a:solidFill>
                   <a:srgbClr val="141414"/>
                 </a:solidFill>
@@ -6744,15 +6748,15 @@
               </a:defRPr>
             </a:pPr>
             <a:r>
-              <a:t>■  Pengguna tablet tidak perlu bolak-balik menekan tombol 'Back' untuk membaca isi berkas.</a:t>
+              <a:t>■  ⚡ Efisiensi 2x Lipat: Pengguna tablet tidak perlu lelah bolak-balik menekan tombol 'Back' hanya untuk membaca rincian data.</a:t>
             </a:r>
           </a:p>
           <a:p>
             <a:pPr>
               <a:spcAft>
-                <a:spcPts val="800"/>
+                <a:spcPts val="600"/>
               </a:spcAft>
-              <a:defRPr sz="1050">
+              <a:defRPr sz="980">
                 <a:solidFill>
                   <a:srgbClr val="141414"/>
                 </a:solidFill>
@@ -6760,7 +6764,7 @@
               </a:defRPr>
             </a:pPr>
             <a:r>
-              <a:t>■  Merupakan pola desain antarmuka wajib pada aplikasi email, pesan chat, dan katalog e-commerce.</a:t>
+              <a:t>■  🏛️ Standar Industri: Pola arsitektur wajib untuk aplikasi e-commerce, portal berita, email, dan catatan medis rumah sakit.</a:t>
             </a:r>
           </a:p>
         </p:txBody>
@@ -6773,8 +6777,8 @@
         </p:nvSpPr>
         <p:spPr>
           <a:xfrm>
-            <a:off x="960120" y="5074920"/>
-            <a:ext cx="4114800" cy="1005840"/>
+            <a:off x="960120" y="5047488"/>
+            <a:ext cx="4114800" cy="1051560"/>
           </a:xfrm>
           <a:prstGeom prst="rect">
             <a:avLst/>
@@ -6818,8 +6822,8 @@
         </p:nvSpPr>
         <p:spPr>
           <a:xfrm>
-            <a:off x="1005840" y="5102352"/>
-            <a:ext cx="4023360" cy="914400"/>
+            <a:off x="1005840" y="5074920"/>
+            <a:ext cx="4023360" cy="960120"/>
           </a:xfrm>
           <a:prstGeom prst="rect">
             <a:avLst/>
@@ -6833,7 +6837,7 @@
           <a:lstStyle/>
           <a:p>
             <a:pPr>
-              <a:defRPr sz="950" b="1">
+              <a:defRPr sz="919" b="1">
                 <a:solidFill>
                   <a:srgbClr val="000000"/>
                 </a:solidFill>
@@ -6841,11 +6845,11 @@
               </a:defRPr>
             </a:pPr>
             <a:r>
-              <a:t>💡 TIPS PRAKTIKUM:</a:t>
+              <a:t>💡 TIPS PRAKTIKUM &amp; PEDOMAN:</a:t>
             </a:r>
             <a:br/>
             <a:r>
-              <a:t>Pola Master-Detail meningkatkan produktivitas pengguna tablet hingga 2 kali lipat!</a:t>
+              <a:t>Pola Master-Detail meningkatkan produktivitas pengguna tablet hingga dua kali lipat!</a:t>
             </a:r>
           </a:p>
         </p:txBody>
@@ -7062,11 +7066,11 @@
             </a:r>
             <a:br/>
             <a:r>
-              <a:t>      SizedBox(width: 300, child: MasterList()),</a:t>
+              <a:t>      SizedBox(width: 300, child: MasterList()), // Kiri: Daftar</a:t>
             </a:r>
             <a:br/>
             <a:r>
-              <a:t>      Expanded(child: DetailView(selectedItem)),</a:t>
+              <a:t>      Expanded(child: DetailView(selectedItem)),  // Kanan: Rincian</a:t>
             </a:r>
             <a:br/>
             <a:r>
@@ -7082,7 +7086,7 @@
             </a:r>
             <a:br/>
             <a:r>
-              <a:t>  MasterList(); // Di ponsel: push() ke layar baru</a:t>
+              <a:t>  MasterList(); // Di ponsel: push() ke layar rincian baru</a:t>
             </a:r>
           </a:p>
         </p:txBody>
@@ -7432,7 +7436,7 @@
               </a:defRPr>
             </a:pPr>
             <a:r>
-              <a:t>Komponen .adaptive(): Otomatis Rasa Android &amp; iOS</a:t>
+              <a:t>Widget Adaptif: Colokan Adaptor Universal Internasional</a:t>
             </a:r>
           </a:p>
         </p:txBody>
@@ -7601,7 +7605,7 @@
               </a:defRPr>
             </a:pPr>
             <a:r>
-              <a:t>💡 KONSEP INTI &amp; CARA KERJA</a:t>
+              <a:t>💡 KONSEP INTI &amp; ANALOGI AWAM</a:t>
             </a:r>
           </a:p>
         </p:txBody>
@@ -7614,8 +7618,8 @@
         </p:nvSpPr>
         <p:spPr>
           <a:xfrm>
-            <a:off x="1005840" y="2176272"/>
-            <a:ext cx="4023360" cy="2926080"/>
+            <a:off x="1005840" y="2157984"/>
+            <a:ext cx="4023360" cy="2834640"/>
           </a:xfrm>
           <a:prstGeom prst="rect">
             <a:avLst/>
@@ -7630,9 +7634,9 @@
           <a:p>
             <a:pPr>
               <a:spcAft>
-                <a:spcPts val="800"/>
+                <a:spcPts val="600"/>
               </a:spcAft>
-              <a:defRPr sz="1050">
+              <a:defRPr sz="980">
                 <a:solidFill>
                   <a:srgbClr val="141414"/>
                 </a:solidFill>
@@ -7640,15 +7644,15 @@
               </a:defRPr>
             </a:pPr>
             <a:r>
-              <a:t>■  Flutter menyediakan konstruktor khusus '.adaptive()' untuk komponen yang memiliki perbedaan gaya drastis.</a:t>
+              <a:t>■  🔌 Analogi Steker Adaptor: Satu colokan charger yang otomatis cocok di stopkontak Indonesia maupun stopkontak luar negeri tanpa adaptor tambahan.</a:t>
             </a:r>
           </a:p>
           <a:p>
             <a:pPr>
               <a:spcAft>
-                <a:spcPts val="800"/>
+                <a:spcPts val="600"/>
               </a:spcAft>
-              <a:defRPr sz="1050">
+              <a:defRPr sz="980">
                 <a:solidFill>
                   <a:srgbClr val="141414"/>
                 </a:solidFill>
@@ -7656,15 +7660,15 @@
               </a:defRPr>
             </a:pPr>
             <a:r>
-              <a:t>■  Contoh: 'Switch.adaptive()' akan bergaya Material 3 di Android/Web, dan bergaya saklar hijau lonjong di iPhone.</a:t>
+              <a:t>■  🔄 Konstruktor '.adaptive()': Flutter menyediakan komponen yang otomatis berubah bentuk mengikuti gaya asli sistem operasi perangkat.</a:t>
             </a:r>
           </a:p>
           <a:p>
             <a:pPr>
               <a:spcAft>
-                <a:spcPts val="800"/>
+                <a:spcPts val="600"/>
               </a:spcAft>
-              <a:defRPr sz="1050">
+              <a:defRPr sz="980">
                 <a:solidFill>
                   <a:srgbClr val="141414"/>
                 </a:solidFill>
@@ -7672,15 +7676,15 @@
               </a:defRPr>
             </a:pPr>
             <a:r>
-              <a:t>■  'CircularProgressIndicator.adaptive()' menampilkan lingkaran putar di Android dan pemintal abu di iOS.</a:t>
+              <a:t>■  🟢 Switch.adaptive(): Tampil saklar Material 3 di Android/Web, dan saklar bulat hijau lonjong khas iOS di perangkat iPhone/iPad.</a:t>
             </a:r>
           </a:p>
           <a:p>
             <a:pPr>
               <a:spcAft>
-                <a:spcPts val="800"/>
+                <a:spcPts val="600"/>
               </a:spcAft>
-              <a:defRPr sz="1050">
+              <a:defRPr sz="980">
                 <a:solidFill>
                   <a:srgbClr val="141414"/>
                 </a:solidFill>
@@ -7688,7 +7692,7 @@
               </a:defRPr>
             </a:pPr>
             <a:r>
-              <a:t>■  Memberikan sensasi aplikasi asli (*native feel*) tanpa perlu menulis percabangan kode 'if (Platform.isIOS)' manual.</a:t>
+              <a:t>■  ⏳ CircularProgressIndicator.adaptive(): Berputar gaya Material di Android dan animasi pemintal abu-abu khas Cupertino di iOS.</a:t>
             </a:r>
           </a:p>
         </p:txBody>
@@ -7701,8 +7705,8 @@
         </p:nvSpPr>
         <p:spPr>
           <a:xfrm>
-            <a:off x="960120" y="5074920"/>
-            <a:ext cx="4114800" cy="1005840"/>
+            <a:off x="960120" y="5047488"/>
+            <a:ext cx="4114800" cy="1051560"/>
           </a:xfrm>
           <a:prstGeom prst="rect">
             <a:avLst/>
@@ -7746,8 +7750,8 @@
         </p:nvSpPr>
         <p:spPr>
           <a:xfrm>
-            <a:off x="1005840" y="5102352"/>
-            <a:ext cx="4023360" cy="914400"/>
+            <a:off x="1005840" y="5074920"/>
+            <a:ext cx="4023360" cy="960120"/>
           </a:xfrm>
           <a:prstGeom prst="rect">
             <a:avLst/>
@@ -7761,7 +7765,7 @@
           <a:lstStyle/>
           <a:p>
             <a:pPr>
-              <a:defRPr sz="950" b="1">
+              <a:defRPr sz="919" b="1">
                 <a:solidFill>
                   <a:srgbClr val="000000"/>
                 </a:solidFill>
@@ -7769,11 +7773,11 @@
               </a:defRPr>
             </a:pPr>
             <a:r>
-              <a:t>💡 TIPS PRAKTIKUM:</a:t>
+              <a:t>💡 TIPS PRAKTIKUM &amp; PEDOMAN:</a:t>
             </a:r>
             <a:br/>
             <a:r>
-              <a:t>Gunakan konstruktor .adaptive() untuk elemen kontrol formulir lintas platform!</a:t>
+              <a:t>Gunakan Switch.adaptive() dan Slider.adaptive() agar aplikasi Anda berasa native di Android dan iPhone!</a:t>
             </a:r>
           </a:p>
         </p:txBody>
@@ -7978,7 +7982,7 @@
               </a:defRPr>
             </a:pPr>
             <a:r>
-              <a:t>// Saklar otomatis menyesuaikan OS:</a:t>
+              <a:t>// Saklar otomatis menyesuaikan Android / iOS:</a:t>
             </a:r>
             <a:br/>
             <a:r>
@@ -7999,7 +8003,7 @@
             <a:br/>
             <a:br/>
             <a:r>
-              <a:t>// Loading spinner otomatis:</a:t>
+              <a:t>// Loading spinner otomatis bergaya native OS:</a:t>
             </a:r>
             <a:br/>
             <a:r>
@@ -8353,7 +8357,7 @@
               </a:defRPr>
             </a:pPr>
             <a:r>
-              <a:t>Membangun Komponen Kit: Kartu Statistik Kuliah</a:t>
+              <a:t>Reusable Component Kit: Balok LEGO Standar Berkualitas</a:t>
             </a:r>
           </a:p>
         </p:txBody>
@@ -8522,7 +8526,7 @@
               </a:defRPr>
             </a:pPr>
             <a:r>
-              <a:t>💡 KONSEP INTI &amp; CARA KERJA</a:t>
+              <a:t>💡 KONSEP INTI &amp; ANALOGI AWAM</a:t>
             </a:r>
           </a:p>
         </p:txBody>
@@ -8535,8 +8539,8 @@
         </p:nvSpPr>
         <p:spPr>
           <a:xfrm>
-            <a:off x="1005840" y="2176272"/>
-            <a:ext cx="4023360" cy="2926080"/>
+            <a:off x="1005840" y="2157984"/>
+            <a:ext cx="4023360" cy="2834640"/>
           </a:xfrm>
           <a:prstGeom prst="rect">
             <a:avLst/>
@@ -8551,9 +8555,9 @@
           <a:p>
             <a:pPr>
               <a:spcAft>
-                <a:spcPts val="800"/>
+                <a:spcPts val="600"/>
               </a:spcAft>
-              <a:defRPr sz="1050">
+              <a:defRPr sz="980">
                 <a:solidFill>
                   <a:srgbClr val="141414"/>
                 </a:solidFill>
@@ -8561,15 +8565,15 @@
               </a:defRPr>
             </a:pPr>
             <a:r>
-              <a:t>■  Aplikasi profesional tidak menduplikasi kode tata letak berulang-ulang (*Don't Repeat Yourself / DRY*).</a:t>
+              <a:t>■  🧱 Analogi Balok LEGO: Membangun istana megah dari balok LEGO standar yang rapi, bukan mencetak ulang cetakan plastik dari nol setiap saat!</a:t>
             </a:r>
           </a:p>
           <a:p>
             <a:pPr>
               <a:spcAft>
-                <a:spcPts val="800"/>
+                <a:spcPts val="600"/>
               </a:spcAft>
-              <a:defRPr sz="1050">
+              <a:defRPr sz="980">
                 <a:solidFill>
                   <a:srgbClr val="141414"/>
                 </a:solidFill>
@@ -8577,15 +8581,15 @@
               </a:defRPr>
             </a:pPr>
             <a:r>
-              <a:t>■  Bungkus pola UI yang sering dipakai ke dalam StatelessWidget tersendiri (misal: 'StatCard').</a:t>
+              <a:t>■  🚫 Prinsip DRY (Don't Repeat Yourself): Jangan menduplikasi kode kartu statistik berulang kali di berbagai berkas layar.</a:t>
             </a:r>
           </a:p>
           <a:p>
             <a:pPr>
               <a:spcAft>
-                <a:spcPts val="800"/>
+                <a:spcPts val="600"/>
               </a:spcAft>
-              <a:defRPr sz="1050">
+              <a:defRPr sz="980">
                 <a:solidFill>
                   <a:srgbClr val="141414"/>
                 </a:solidFill>
@@ -8593,15 +8597,15 @@
               </a:defRPr>
             </a:pPr>
             <a:r>
-              <a:t>■  Terapkan warna dari 'Theme.of(context).colorScheme' agar kartu otomatis berubah saat tema berganti gelap/terang.</a:t>
+              <a:t>■  📦 Buat Widget Kustom: Bungkus pola UI yang sering dipakai ke dalam StatelessWidget tersendiri (misal: 'StatCard').</a:t>
             </a:r>
           </a:p>
           <a:p>
             <a:pPr>
               <a:spcAft>
-                <a:spcPts val="800"/>
+                <a:spcPts val="600"/>
               </a:spcAft>
-              <a:defRPr sz="1050">
+              <a:defRPr sz="980">
                 <a:solidFill>
                   <a:srgbClr val="141414"/>
                 </a:solidFill>
@@ -8609,7 +8613,7 @@
               </a:defRPr>
             </a:pPr>
             <a:r>
-              <a:t>■  Mendukung konsistensi desain sistem di seluruh tim pengembang mahasiswa.</a:t>
+              <a:t>■  🎨 Desain Token Terpusat: Selalu ambil warna dari 'Theme.of(context).colorScheme' agar kartu otomatis berubah saat tema berganti.</a:t>
             </a:r>
           </a:p>
         </p:txBody>
@@ -8622,8 +8626,8 @@
         </p:nvSpPr>
         <p:spPr>
           <a:xfrm>
-            <a:off x="960120" y="5074920"/>
-            <a:ext cx="4114800" cy="1005840"/>
+            <a:off x="960120" y="5047488"/>
+            <a:ext cx="4114800" cy="1051560"/>
           </a:xfrm>
           <a:prstGeom prst="rect">
             <a:avLst/>
@@ -8667,8 +8671,8 @@
         </p:nvSpPr>
         <p:spPr>
           <a:xfrm>
-            <a:off x="1005840" y="5102352"/>
-            <a:ext cx="4023360" cy="914400"/>
+            <a:off x="1005840" y="5074920"/>
+            <a:ext cx="4023360" cy="960120"/>
           </a:xfrm>
           <a:prstGeom prst="rect">
             <a:avLst/>
@@ -8682,7 +8686,7 @@
           <a:lstStyle/>
           <a:p>
             <a:pPr>
-              <a:defRPr sz="950" b="1">
+              <a:defRPr sz="919" b="1">
                 <a:solidFill>
                   <a:srgbClr val="000000"/>
                 </a:solidFill>
@@ -8690,7 +8694,7 @@
               </a:defRPr>
             </a:pPr>
             <a:r>
-              <a:t>💡 TIPS PRAKTIKUM:</a:t>
+              <a:t>💡 TIPS PRAKTIKUM &amp; PEDOMAN:</a:t>
             </a:r>
             <a:br/>
             <a:r>
@@ -9307,7 +9311,7 @@
               </a:defRPr>
             </a:pPr>
             <a:r>
-              <a:t>FittedBox: Menangani Skala Teks Besar (Anti-Overflow)</a:t>
+              <a:t>FittedBox Scaling: Koper Pakaian Berkemasan Vakum</a:t>
             </a:r>
           </a:p>
         </p:txBody>
@@ -9476,7 +9480,7 @@
               </a:defRPr>
             </a:pPr>
             <a:r>
-              <a:t>💡 KONSEP INTI &amp; CARA KERJA</a:t>
+              <a:t>💡 KONSEP INTI &amp; ANALOGI AWAM</a:t>
             </a:r>
           </a:p>
         </p:txBody>
@@ -9489,8 +9493,8 @@
         </p:nvSpPr>
         <p:spPr>
           <a:xfrm>
-            <a:off x="1005840" y="2176272"/>
-            <a:ext cx="4023360" cy="2926080"/>
+            <a:off x="1005840" y="2157984"/>
+            <a:ext cx="4023360" cy="2834640"/>
           </a:xfrm>
           <a:prstGeom prst="rect">
             <a:avLst/>
@@ -9505,9 +9509,9 @@
           <a:p>
             <a:pPr>
               <a:spcAft>
-                <a:spcPts val="800"/>
+                <a:spcPts val="600"/>
               </a:spcAft>
-              <a:defRPr sz="1050">
+              <a:defRPr sz="980">
                 <a:solidFill>
                   <a:srgbClr val="141414"/>
                 </a:solidFill>
@@ -9515,15 +9519,15 @@
               </a:defRPr>
             </a:pPr>
             <a:r>
-              <a:t>■  Masalah nyata: Pengguna lanjut usia menyetel ukuran teks HP menjadi 150% (Font Scale) di setelan sistem.</a:t>
+              <a:t>■  🧳 Analogi Koper Vakum: Saat baju terlalu tebal, kantong vakum mengempiskannya agar tetap muat rapi di dalam koper tanpa merusak resleting.</a:t>
             </a:r>
           </a:p>
           <a:p>
             <a:pPr>
               <a:spcAft>
-                <a:spcPts val="800"/>
+                <a:spcPts val="600"/>
               </a:spcAft>
-              <a:defRPr sz="1050">
+              <a:defRPr sz="980">
                 <a:solidFill>
                   <a:srgbClr val="141414"/>
                 </a:solidFill>
@@ -9531,15 +9535,15 @@
               </a:defRPr>
             </a:pPr>
             <a:r>
-              <a:t>■  Akibatnya: Angka saldo bank 'Rp 10.000.000' meledak dan memicu error garis kuning-hitam (RenderFlex overflow).</a:t>
+              <a:t>■  💥 Masalah Nyata: Kakek/nenek menyetel pembesaran font HP 150% -&gt; angka saldo bank 'Rp 999.999.999,-' meledak memicu overflow garis kuning-hitam!</a:t>
             </a:r>
           </a:p>
           <a:p>
             <a:pPr>
               <a:spcAft>
-                <a:spcPts val="800"/>
+                <a:spcPts val="600"/>
               </a:spcAft>
-              <a:defRPr sz="1050">
+              <a:defRPr sz="980">
                 <a:solidFill>
                   <a:srgbClr val="141414"/>
                 </a:solidFill>
@@ -9547,15 +9551,15 @@
               </a:defRPr>
             </a:pPr>
             <a:r>
-              <a:t>■  Solusi: Bungkus teks dengan widget 'FittedBox(fit: BoxFit.scaleDown)'.</a:t>
+              <a:t>■  🛡️ Solusi Anggun: Bungkus teks dengan widget sakti: 'FittedBox(fit: BoxFit.scaleDown)'.</a:t>
             </a:r>
           </a:p>
           <a:p>
             <a:pPr>
               <a:spcAft>
-                <a:spcPts val="800"/>
+                <a:spcPts val="600"/>
               </a:spcAft>
-              <a:defRPr sz="1050">
+              <a:defRPr sz="980">
                 <a:solidFill>
                   <a:srgbClr val="141414"/>
                 </a:solidFill>
@@ -9563,7 +9567,7 @@
               </a:defRPr>
             </a:pPr>
             <a:r>
-              <a:t>■  Teks akan otomatis menyusut anggun agar muat di dalam lebar kotak yang disediakan tanpa pernah terpotong.</a:t>
+              <a:t>■  ✨ Menyusut Otomatis: Teks akan otomatis menyusut anggun jika ruang terbatas, dan tetap berukuran normal jika ruang tersedia cukup.</a:t>
             </a:r>
           </a:p>
         </p:txBody>
@@ -9576,8 +9580,8 @@
         </p:nvSpPr>
         <p:spPr>
           <a:xfrm>
-            <a:off x="960120" y="5074920"/>
-            <a:ext cx="4114800" cy="1005840"/>
+            <a:off x="960120" y="5047488"/>
+            <a:ext cx="4114800" cy="1051560"/>
           </a:xfrm>
           <a:prstGeom prst="rect">
             <a:avLst/>
@@ -9621,8 +9625,8 @@
         </p:nvSpPr>
         <p:spPr>
           <a:xfrm>
-            <a:off x="1005840" y="5102352"/>
-            <a:ext cx="4023360" cy="914400"/>
+            <a:off x="1005840" y="5074920"/>
+            <a:ext cx="4023360" cy="960120"/>
           </a:xfrm>
           <a:prstGeom prst="rect">
             <a:avLst/>
@@ -9636,7 +9640,7 @@
           <a:lstStyle/>
           <a:p>
             <a:pPr>
-              <a:defRPr sz="950" b="1">
+              <a:defRPr sz="919" b="1">
                 <a:solidFill>
                   <a:srgbClr val="000000"/>
                 </a:solidFill>
@@ -9644,11 +9648,11 @@
               </a:defRPr>
             </a:pPr>
             <a:r>
-              <a:t>💡 TIPS PRAKTIKUM:</a:t>
+              <a:t>💡 TIPS PRAKTIKUM &amp; PEDOMAN:</a:t>
             </a:r>
             <a:br/>
             <a:r>
-              <a:t>Gunakan FittedBox pada label saldo, harga produk, dan nomor telepon penting!</a:t>
+              <a:t>Wajib pasang FittedBox pada label harga, saldo dompet, nomor rekening, dan kartu identitas!</a:t>
             </a:r>
           </a:p>
         </p:txBody>
@@ -9865,7 +9869,7 @@
             </a:r>
             <a:br/>
             <a:r>
-              <a:t>    fit: BoxFit.scaleDown, // Menyusut jika kepanjangan</a:t>
+              <a:t>    fit: BoxFit.scaleDown, // Otomatis menyusut jika kepanjangan</a:t>
             </a:r>
             <a:br/>
             <a:r>
@@ -10239,7 +10243,7 @@
               </a:defRPr>
             </a:pPr>
             <a:r>
-              <a:t>5 Aturan Emas Desain Antarmuka Mobile Responsif</a:t>
+              <a:t>5 Aturan Emas Desain UI Responsif (Checklist Penilaian UTS)</a:t>
             </a:r>
           </a:p>
         </p:txBody>
@@ -10408,7 +10412,7 @@
               </a:defRPr>
             </a:pPr>
             <a:r>
-              <a:t>💡 KONSEP INTI &amp; CARA KERJA</a:t>
+              <a:t>💡 KONSEP INTI &amp; ANALOGI AWAM</a:t>
             </a:r>
           </a:p>
         </p:txBody>
@@ -10421,8 +10425,8 @@
         </p:nvSpPr>
         <p:spPr>
           <a:xfrm>
-            <a:off x="1005840" y="2176272"/>
-            <a:ext cx="4023360" cy="2926080"/>
+            <a:off x="1005840" y="2157984"/>
+            <a:ext cx="4023360" cy="2834640"/>
           </a:xfrm>
           <a:prstGeom prst="rect">
             <a:avLst/>
@@ -10437,9 +10441,9 @@
           <a:p>
             <a:pPr>
               <a:spcAft>
-                <a:spcPts val="800"/>
+                <a:spcPts val="600"/>
               </a:spcAft>
-              <a:defRPr sz="1050">
+              <a:defRPr sz="980">
                 <a:solidFill>
                   <a:srgbClr val="141414"/>
                 </a:solidFill>
@@ -10447,15 +10451,15 @@
               </a:defRPr>
             </a:pPr>
             <a:r>
-              <a:t>■  1. Dilarang Hardcode Dimensi: Jangan menulis 'width: 360', gunakan Expanded, Flexible, atau MediaQuery.</a:t>
+              <a:t>■  1. Dilarang Hardcode Dimensi: Hindari menulis 'width: 380', gunakan Expanded, Flexible, atau LayoutBuilder.</a:t>
             </a:r>
           </a:p>
           <a:p>
             <a:pPr>
               <a:spcAft>
-                <a:spcPts val="800"/>
+                <a:spcPts val="600"/>
               </a:spcAft>
-              <a:defRPr sz="1050">
+              <a:defRPr sz="980">
                 <a:solidFill>
                   <a:srgbClr val="141414"/>
                 </a:solidFill>
@@ -10463,15 +10467,15 @@
               </a:defRPr>
             </a:pPr>
             <a:r>
-              <a:t>■  2. Hormati Breakpoint 600dp: Pisahkan tata letak 1 kolom ponsel vs multi-kolom tablet.</a:t>
+              <a:t>■  2. Hormati Breakpoint Sakral 600dp: Bedakan tata letak 1 kolom untuk ponsel dan multi-kolom untuk tablet.</a:t>
             </a:r>
           </a:p>
           <a:p>
             <a:pPr>
               <a:spcAft>
-                <a:spcPts val="800"/>
+                <a:spcPts val="600"/>
               </a:spcAft>
-              <a:defRPr sz="1050">
+              <a:defRPr sz="980">
                 <a:solidFill>
                   <a:srgbClr val="141414"/>
                 </a:solidFill>
@@ -10479,15 +10483,15 @@
               </a:defRPr>
             </a:pPr>
             <a:r>
-              <a:t>■  3. Navigasi Adaptif: NavigationBar di bawah untuk ponsel, NavigationRail di samping untuk tablet.</a:t>
+              <a:t>■  3. Navigasi Adaptif Ergonomis: Bottom NavigationBar di ponsel, Side NavigationRail di tablet.</a:t>
             </a:r>
           </a:p>
           <a:p>
             <a:pPr>
               <a:spcAft>
-                <a:spcPts val="800"/>
+                <a:spcPts val="600"/>
               </a:spcAft>
-              <a:defRPr sz="1050">
+              <a:defRPr sz="980">
                 <a:solidFill>
                   <a:srgbClr val="141414"/>
                 </a:solidFill>
@@ -10495,15 +10499,15 @@
               </a:defRPr>
             </a:pPr>
             <a:r>
-              <a:t>■  4. Uji Rotasi Landscape: Pastikan antarmuka tidak terpotong saat layar dimiringkan.</a:t>
+              <a:t>■  4. Lolos Uji Rotasi Layar: Pastikan antarmuka tidak terpotong saat layar dimiringkan horizontal.</a:t>
             </a:r>
           </a:p>
           <a:p>
             <a:pPr>
               <a:spcAft>
-                <a:spcPts val="800"/>
+                <a:spcPts val="600"/>
               </a:spcAft>
-              <a:defRPr sz="1050">
+              <a:defRPr sz="980">
                 <a:solidFill>
                   <a:srgbClr val="141414"/>
                 </a:solidFill>
@@ -10511,7 +10515,7 @@
               </a:defRPr>
             </a:pPr>
             <a:r>
-              <a:t>■  5. Cek Uji Kontras Light/Dark: Pastikan teks terbaca jelas pada tema terang maupun gelap.</a:t>
+              <a:t>■  5. Kontras Warna Sempurna: Pastikan teks terbaca jelas di Tema Terang maupun Tema Gelap.</a:t>
             </a:r>
           </a:p>
         </p:txBody>
@@ -10524,8 +10528,8 @@
         </p:nvSpPr>
         <p:spPr>
           <a:xfrm>
-            <a:off x="960120" y="5074920"/>
-            <a:ext cx="4114800" cy="1005840"/>
+            <a:off x="960120" y="5047488"/>
+            <a:ext cx="4114800" cy="1051560"/>
           </a:xfrm>
           <a:prstGeom prst="rect">
             <a:avLst/>
@@ -10569,8 +10573,8 @@
         </p:nvSpPr>
         <p:spPr>
           <a:xfrm>
-            <a:off x="1005840" y="5102352"/>
-            <a:ext cx="4023360" cy="914400"/>
+            <a:off x="1005840" y="5074920"/>
+            <a:ext cx="4023360" cy="960120"/>
           </a:xfrm>
           <a:prstGeom prst="rect">
             <a:avLst/>
@@ -10584,7 +10588,7 @@
           <a:lstStyle/>
           <a:p>
             <a:pPr>
-              <a:defRPr sz="950" b="1">
+              <a:defRPr sz="919" b="1">
                 <a:solidFill>
                   <a:srgbClr val="000000"/>
                 </a:solidFill>
@@ -10592,11 +10596,11 @@
               </a:defRPr>
             </a:pPr>
             <a:r>
-              <a:t>💡 TIPS PRAKTIKUM:</a:t>
+              <a:t>💡 TIPS PRAKTIKUM &amp; PEDOMAN:</a:t>
             </a:r>
             <a:br/>
             <a:r>
-              <a:t>Jadikan kelima checklist ini sebagai acuan penilaian proyek UTS kelompok Anda!</a:t>
+              <a:t>Jadikan kelima checklist ini sebagai acuan penilaian proyek UTS kelompok Anda agar meraih nilai A!</a:t>
             </a:r>
           </a:p>
         </p:txBody>
@@ -10801,15 +10805,15 @@
               </a:defRPr>
             </a:pPr>
             <a:r>
-              <a:t>// Checklist Uji Praktikum Responsif:</a:t>
+              <a:t>// Checklist Uji Praktikum Responsif Standar 2026:</a:t>
             </a:r>
             <a:br/>
             <a:r>
-              <a:t>// [✓] Tampilan tidak overflow saat jendela ditarik sempit</a:t>
+              <a:t>// [✓] Tampilan bebas dari overflow garis kuning-hitam</a:t>
             </a:r>
             <a:br/>
             <a:r>
-              <a:t>// [✓] Menu pindah ke samping saat layar melebihi 600dp</a:t>
+              <a:t>// [✓] Navigasi pindah ke samping saat layar melebihi 600dp</a:t>
             </a:r>
             <a:br/>
             <a:r>
@@ -10817,7 +10821,7 @@
             </a:r>
             <a:br/>
             <a:r>
-              <a:t>// [✓] Berjalan mulus di Chrome Web &amp; Ponsel Fisik</a:t>
+              <a:t>// [✓] Berjalan mulus di Chrome Web &amp; Smartphone Fisik</a:t>
             </a:r>
           </a:p>
         </p:txBody>
@@ -11821,7 +11825,7 @@
               </a:defRPr>
             </a:pPr>
             <a:r>
-              <a:t>Menguji UI Responsif di Browser Chrome (Hemat RAM)</a:t>
+              <a:t>Menguji UI Responsif di Chrome (Hemat RAM &amp; Anti-Lag)</a:t>
             </a:r>
           </a:p>
         </p:txBody>
@@ -11990,7 +11994,7 @@
               </a:defRPr>
             </a:pPr>
             <a:r>
-              <a:t>💡 KONSEP INTI &amp; CARA KERJA</a:t>
+              <a:t>💡 KONSEP INTI &amp; ANALOGI AWAM</a:t>
             </a:r>
           </a:p>
         </p:txBody>
@@ -12003,8 +12007,8 @@
         </p:nvSpPr>
         <p:spPr>
           <a:xfrm>
-            <a:off x="1005840" y="2176272"/>
-            <a:ext cx="4023360" cy="2926080"/>
+            <a:off x="1005840" y="2157984"/>
+            <a:ext cx="4023360" cy="2834640"/>
           </a:xfrm>
           <a:prstGeom prst="rect">
             <a:avLst/>
@@ -12019,9 +12023,9 @@
           <a:p>
             <a:pPr>
               <a:spcAft>
-                <a:spcPts val="800"/>
+                <a:spcPts val="600"/>
               </a:spcAft>
-              <a:defRPr sz="1050">
+              <a:defRPr sz="980">
                 <a:solidFill>
                   <a:srgbClr val="141414"/>
                 </a:solidFill>
@@ -12029,15 +12033,15 @@
               </a:defRPr>
             </a:pPr>
             <a:r>
-              <a:t>■  Tidak perlu membeli banyak perangkat fisik atau membuka emulator tablet yang sangat berat di PC lab.</a:t>
+              <a:t>■  💡 Analogi Simulator: Emulator Android Studio di PC lab sering berat seperti helikopter. Gunakan Chrome sebagai simulator super ringan!</a:t>
             </a:r>
           </a:p>
           <a:p>
             <a:pPr>
               <a:spcAft>
-                <a:spcPts val="800"/>
+                <a:spcPts val="600"/>
               </a:spcAft>
-              <a:defRPr sz="1050">
+              <a:defRPr sz="980">
                 <a:solidFill>
                   <a:srgbClr val="141414"/>
                 </a:solidFill>
@@ -12045,15 +12049,15 @@
               </a:defRPr>
             </a:pPr>
             <a:r>
-              <a:t>■  Cukup jalankan: 'flutter run -d chrome'. Peramban web Google Chrome memakan RAM &lt; 150MB.</a:t>
+              <a:t>■  🚀 Cukup jalankan: 'flutter run -d chrome'. Konsumsi RAM di bawah 150MB sehingga laptop berspesifikasi pas-pasan tetap lancar jaya.</a:t>
             </a:r>
           </a:p>
           <a:p>
             <a:pPr>
               <a:spcAft>
-                <a:spcPts val="800"/>
+                <a:spcPts val="600"/>
               </a:spcAft>
-              <a:defRPr sz="1050">
+              <a:defRPr sz="980">
                 <a:solidFill>
                   <a:srgbClr val="141414"/>
                 </a:solidFill>
@@ -12061,15 +12065,15 @@
               </a:defRPr>
             </a:pPr>
             <a:r>
-              <a:t>■  Tarik sisi kanan jendela Chrome untuk menyimulasikan layar ponsel (lebar &lt;600dp) hingga layar tablet/desktop (&gt;840dp).</a:t>
+              <a:t>■  ↔️ Efek Karet Gelang: Cukup tarik tepi jendela Chrome untuk menyimulasikan layar ponsel (&lt;600dp), tablet (600-840dp), hingga laptop (&gt;840dp).</a:t>
             </a:r>
           </a:p>
           <a:p>
             <a:pPr>
               <a:spcAft>
-                <a:spcPts val="800"/>
+                <a:spcPts val="600"/>
               </a:spcAft>
-              <a:defRPr sz="1050">
+              <a:defRPr sz="980">
                 <a:solidFill>
                   <a:srgbClr val="141414"/>
                 </a:solidFill>
@@ -12077,7 +12081,7 @@
               </a:defRPr>
             </a:pPr>
             <a:r>
-              <a:t>■  Hot Reload (&lt;1 detik) membuat iterasi desain responsif menjadi sangat instan dan menyenangkan.</a:t>
+              <a:t>■  ⚡ Fitur Hot Reload instan (&lt;1 detik) membuat Anda bisa melihat adaptasi tata letak secara langsung tanpa perlu restart.</a:t>
             </a:r>
           </a:p>
         </p:txBody>
@@ -12090,8 +12094,8 @@
         </p:nvSpPr>
         <p:spPr>
           <a:xfrm>
-            <a:off x="960120" y="5074920"/>
-            <a:ext cx="4114800" cy="1005840"/>
+            <a:off x="960120" y="5047488"/>
+            <a:ext cx="4114800" cy="1051560"/>
           </a:xfrm>
           <a:prstGeom prst="rect">
             <a:avLst/>
@@ -12135,8 +12139,8 @@
         </p:nvSpPr>
         <p:spPr>
           <a:xfrm>
-            <a:off x="1005840" y="5102352"/>
-            <a:ext cx="4023360" cy="914400"/>
+            <a:off x="1005840" y="5074920"/>
+            <a:ext cx="4023360" cy="960120"/>
           </a:xfrm>
           <a:prstGeom prst="rect">
             <a:avLst/>
@@ -12150,7 +12154,7 @@
           <a:lstStyle/>
           <a:p>
             <a:pPr>
-              <a:defRPr sz="950" b="1">
+              <a:defRPr sz="919" b="1">
                 <a:solidFill>
                   <a:srgbClr val="000000"/>
                 </a:solidFill>
@@ -12158,11 +12162,11 @@
               </a:defRPr>
             </a:pPr>
             <a:r>
-              <a:t>💡 TIPS PRAKTIKUM:</a:t>
+              <a:t>💡 TIPS PRAKTIKUM &amp; PEDOMAN:</a:t>
             </a:r>
             <a:br/>
             <a:r>
-              <a:t>Gunakan 'flutter run -d chrome' untuk menghemat memori PC laboratorium Anda!</a:t>
+              <a:t>Tarik pinggir jendela Chrome untuk menguji responsivitas tanpa perlu emulator berat!</a:t>
             </a:r>
           </a:p>
         </p:txBody>
@@ -12735,7 +12739,7 @@
               </a:defRPr>
             </a:pPr>
             <a:r>
-              <a:t>Filosofi Material 3: Sudut Alami &amp; Komponen Modern</a:t>
+              <a:t>Filosofi Material 3: Sudut Alami, Tombol, &amp; 3 Varian Kartu</a:t>
             </a:r>
           </a:p>
         </p:txBody>
@@ -12904,7 +12908,7 @@
               </a:defRPr>
             </a:pPr>
             <a:r>
-              <a:t>💡 KONSEP INTI &amp; CARA KERJA</a:t>
+              <a:t>💡 KONSEP INTI &amp; ANALOGI AWAM</a:t>
             </a:r>
           </a:p>
         </p:txBody>
@@ -12917,8 +12921,8 @@
         </p:nvSpPr>
         <p:spPr>
           <a:xfrm>
-            <a:off x="1005840" y="2176272"/>
-            <a:ext cx="4023360" cy="2926080"/>
+            <a:off x="1005840" y="2157984"/>
+            <a:ext cx="4023360" cy="2834640"/>
           </a:xfrm>
           <a:prstGeom prst="rect">
             <a:avLst/>
@@ -12933,9 +12937,9 @@
           <a:p>
             <a:pPr>
               <a:spcAft>
-                <a:spcPts val="800"/>
+                <a:spcPts val="600"/>
               </a:spcAft>
-              <a:defRPr sz="1050">
+              <a:defRPr sz="980">
                 <a:solidFill>
                   <a:srgbClr val="141414"/>
                 </a:solidFill>
@@ -12943,15 +12947,15 @@
               </a:defRPr>
             </a:pPr>
             <a:r>
-              <a:t>■  Material 3 adalah evolusi desain antarmuka resmi Google untuk Android 12 ke atas dan lintas platform.</a:t>
+              <a:t>■  🛋️ Analogi Furnitur Modern: M3 hadir layaknya sofa Skandinavia minimalis—tanpa sudut tajam menusuk, bayangan lembut, dan warna menyejukkan.</a:t>
             </a:r>
           </a:p>
           <a:p>
             <a:pPr>
               <a:spcAft>
-                <a:spcPts val="800"/>
+                <a:spcPts val="600"/>
               </a:spcAft>
-              <a:defRPr sz="1050">
+              <a:defRPr sz="980">
                 <a:solidFill>
                   <a:srgbClr val="141414"/>
                 </a:solidFill>
@@ -12959,15 +12963,15 @@
               </a:defRPr>
             </a:pPr>
             <a:r>
-              <a:t>■  Ciri khas utama: Sudut membulat alami (12dp s.d. 16dp), bayangan elevasi halus, dan tombol hierarki tonal.</a:t>
+              <a:t>■  🔘 Tombol Modern: Gunakan 'FilledButton' (aksi utama kontras), 'FilledButton.tonal' (aksi sekunder lembut), dan 'OutlinedButton'.</a:t>
             </a:r>
           </a:p>
           <a:p>
             <a:pPr>
               <a:spcAft>
-                <a:spcPts val="800"/>
+                <a:spcPts val="600"/>
               </a:spcAft>
-              <a:defRPr sz="1050">
+              <a:defRPr sz="980">
                 <a:solidFill>
                   <a:srgbClr val="141414"/>
                 </a:solidFill>
@@ -12975,15 +12979,15 @@
               </a:defRPr>
             </a:pPr>
             <a:r>
-              <a:t>■  Komponen tombol standar M3: 'FilledButton' (aksi utama), 'FilledButton.tonal' (aksi sekunder), dan 'OutlinedButton'.</a:t>
+              <a:t>■  🃏 3 Varian Kartu M3: 'Card()' (elevated/melayang halus), 'Card.filled()' (rata warna tonal), dan 'Card.outlined()' (garis tepi halus).</a:t>
             </a:r>
           </a:p>
           <a:p>
             <a:pPr>
               <a:spcAft>
-                <a:spcPts val="800"/>
+                <a:spcPts val="600"/>
               </a:spcAft>
-              <a:defRPr sz="1050">
+              <a:defRPr sz="980">
                 <a:solidFill>
                   <a:srgbClr val="141414"/>
                 </a:solidFill>
@@ -12991,7 +12995,7 @@
               </a:defRPr>
             </a:pPr>
             <a:r>
-              <a:t>■  Wajib diaktifkan di Flutter dengan menetapkan: 'useMaterial3: true' di dalam ThemeData.</a:t>
+              <a:t>■  ⚙️ Syarat Wajib: Selalu pasang 'useMaterial3: true' di dalam ThemeData agar komponen otomatis beralih ke standar modern 2026.</a:t>
             </a:r>
           </a:p>
         </p:txBody>
@@ -13004,8 +13008,8 @@
         </p:nvSpPr>
         <p:spPr>
           <a:xfrm>
-            <a:off x="960120" y="5074920"/>
-            <a:ext cx="4114800" cy="1005840"/>
+            <a:off x="960120" y="5047488"/>
+            <a:ext cx="4114800" cy="1051560"/>
           </a:xfrm>
           <a:prstGeom prst="rect">
             <a:avLst/>
@@ -13049,8 +13053,8 @@
         </p:nvSpPr>
         <p:spPr>
           <a:xfrm>
-            <a:off x="1005840" y="5102352"/>
-            <a:ext cx="4023360" cy="914400"/>
+            <a:off x="1005840" y="5074920"/>
+            <a:ext cx="4023360" cy="960120"/>
           </a:xfrm>
           <a:prstGeom prst="rect">
             <a:avLst/>
@@ -13064,7 +13068,7 @@
           <a:lstStyle/>
           <a:p>
             <a:pPr>
-              <a:defRPr sz="950" b="1">
+              <a:defRPr sz="919" b="1">
                 <a:solidFill>
                   <a:srgbClr val="000000"/>
                 </a:solidFill>
@@ -13072,11 +13076,11 @@
               </a:defRPr>
             </a:pPr>
             <a:r>
-              <a:t>💡 TIPS PRAKTIKUM:</a:t>
+              <a:t>💡 TIPS PRAKTIKUM &amp; PEDOMAN:</a:t>
             </a:r>
             <a:br/>
             <a:r>
-              <a:t>Gunakan FilledButton sebagai pengganti ElevatedButton lama untuk standar UI 2026!</a:t>
+              <a:t>Gunakan Card.outlined untuk tampilan bersih dan FilledButton untuk tombol aksi utama!</a:t>
             </a:r>
           </a:p>
         </p:txBody>
@@ -13301,27 +13305,31 @@
             </a:r>
             <a:br/>
             <a:r>
-              <a:t>  home: const Scaffold(</a:t>
+              <a:t>  home: Scaffold(</a:t>
             </a:r>
             <a:br/>
             <a:r>
-              <a:t>    body: Center(</a:t>
+              <a:t>    body: Column(</a:t>
             </a:r>
             <a:br/>
             <a:r>
-              <a:t>      child: FilledButton(</a:t>
+              <a:t>      children: [</a:t>
             </a:r>
             <a:br/>
             <a:r>
-              <a:t>        onPressed: null,</a:t>
+              <a:t>        FilledButton(onPressed: (){}, child: Text('Aksi')),</a:t>
             </a:r>
             <a:br/>
             <a:r>
-              <a:t>        child: Text('Tombol Material 3'),</a:t>
+              <a:t>        Card(child: Text('Card Elevated')),</a:t>
             </a:r>
             <a:br/>
             <a:r>
-              <a:t>      ),</a:t>
+              <a:t>        Card.outlined(child: Text('Card Outlined')),</a:t>
+            </a:r>
+            <a:br/>
+            <a:r>
+              <a:t>      ],</a:t>
             </a:r>
             <a:br/>
             <a:r>
@@ -13683,7 +13691,7 @@
               </a:defRPr>
             </a:pPr>
             <a:r>
-              <a:t>ColorScheme Seed: Satu Warna Menghasilkan Seluruh Tema</a:t>
+              <a:t>ColorScheme Seed: Pohon Warna Harmonis &amp; Aturan Kaus-Sablon</a:t>
             </a:r>
           </a:p>
         </p:txBody>
@@ -13852,7 +13860,7 @@
               </a:defRPr>
             </a:pPr>
             <a:r>
-              <a:t>💡 KONSEP INTI &amp; CARA KERJA</a:t>
+              <a:t>💡 KONSEP INTI &amp; ANALOGI AWAM</a:t>
             </a:r>
           </a:p>
         </p:txBody>
@@ -13865,8 +13873,8 @@
         </p:nvSpPr>
         <p:spPr>
           <a:xfrm>
-            <a:off x="1005840" y="2176272"/>
-            <a:ext cx="4023360" cy="2926080"/>
+            <a:off x="1005840" y="2157984"/>
+            <a:ext cx="4023360" cy="2834640"/>
           </a:xfrm>
           <a:prstGeom prst="rect">
             <a:avLst/>
@@ -13881,9 +13889,9 @@
           <a:p>
             <a:pPr>
               <a:spcAft>
-                <a:spcPts val="800"/>
+                <a:spcPts val="600"/>
               </a:spcAft>
-              <a:defRPr sz="1050">
+              <a:defRPr sz="980">
                 <a:solidFill>
                   <a:srgbClr val="141414"/>
                 </a:solidFill>
@@ -13891,15 +13899,15 @@
               </a:defRPr>
             </a:pPr>
             <a:r>
-              <a:t>■  Di era Material 3, Anda tidak perlu lagi menentukan puluhan kode warna heksadesimal secara manual!</a:t>
+              <a:t>■  🌱 Analogi Pohon Warna: Anda tanam 1 biji benih ('colorSchemeSeed: Colors.teal'), Google menumbuhkan 30+ warna daun &amp; bunga harmonis otomatis!</a:t>
             </a:r>
           </a:p>
           <a:p>
             <a:pPr>
               <a:spcAft>
-                <a:spcPts val="800"/>
+                <a:spcPts val="600"/>
               </a:spcAft>
-              <a:defRPr sz="1050">
+              <a:defRPr sz="980">
                 <a:solidFill>
                   <a:srgbClr val="141414"/>
                 </a:solidFill>
@@ -13907,15 +13915,15 @@
               </a:defRPr>
             </a:pPr>
             <a:r>
-              <a:t>■  Cukup sediakan satu warna benih: 'colorSchemeSeed: Colors.teal'.</a:t>
+              <a:t>■  👕 Aturan Kaus &amp; Sablon (Prefix 'on'): Jika kaus berwarna gelap ('primary'), tinta tulisan di atasnya wajib ('onPrimary'). Jangan sablon gelap di atas gelap!</a:t>
             </a:r>
           </a:p>
           <a:p>
             <a:pPr>
               <a:spcAft>
-                <a:spcPts val="800"/>
+                <a:spcPts val="600"/>
               </a:spcAft>
-              <a:defRPr sz="1050">
+              <a:defRPr sz="980">
                 <a:solidFill>
                   <a:srgbClr val="141414"/>
                 </a:solidFill>
@@ -13923,15 +13931,15 @@
               </a:defRPr>
             </a:pPr>
             <a:r>
-              <a:t>■  Flutter otomatis menghitung palet harmonis: 'primary', 'primaryContainer', 'secondary', 'surface', dsb.</a:t>
+              <a:t>■  📦 Pasangan Kontainer: Gunakan 'primaryContainer' (warna wadah kotak) dipadukan dengan 'onPrimaryContainer' (warna teks di dalamnya).</a:t>
             </a:r>
           </a:p>
           <a:p>
             <a:pPr>
               <a:spcAft>
-                <a:spcPts val="800"/>
+                <a:spcPts val="600"/>
               </a:spcAft>
-              <a:defRPr sz="1050">
+              <a:defRPr sz="980">
                 <a:solidFill>
                   <a:srgbClr val="141414"/>
                 </a:solidFill>
@@ -13939,7 +13947,7 @@
               </a:defRPr>
             </a:pPr>
             <a:r>
-              <a:t>■  Dapat dibaca di mana saja melalui: 'Theme.of(context).colorScheme'.</a:t>
+              <a:t>■  🎯 Cara Memanggil: Ambil seluruh palet warna aktif di widget mana saja melalui: 'Theme.of(context).colorScheme'.</a:t>
             </a:r>
           </a:p>
         </p:txBody>
@@ -13952,8 +13960,8 @@
         </p:nvSpPr>
         <p:spPr>
           <a:xfrm>
-            <a:off x="960120" y="5074920"/>
-            <a:ext cx="4114800" cy="1005840"/>
+            <a:off x="960120" y="5047488"/>
+            <a:ext cx="4114800" cy="1051560"/>
           </a:xfrm>
           <a:prstGeom prst="rect">
             <a:avLst/>
@@ -13997,8 +14005,8 @@
         </p:nvSpPr>
         <p:spPr>
           <a:xfrm>
-            <a:off x="1005840" y="5102352"/>
-            <a:ext cx="4023360" cy="914400"/>
+            <a:off x="1005840" y="5074920"/>
+            <a:ext cx="4023360" cy="960120"/>
           </a:xfrm>
           <a:prstGeom prst="rect">
             <a:avLst/>
@@ -14012,7 +14020,7 @@
           <a:lstStyle/>
           <a:p>
             <a:pPr>
-              <a:defRPr sz="950" b="1">
+              <a:defRPr sz="919" b="1">
                 <a:solidFill>
                   <a:srgbClr val="000000"/>
                 </a:solidFill>
@@ -14020,11 +14028,11 @@
               </a:defRPr>
             </a:pPr>
             <a:r>
-              <a:t>💡 TIPS PRAKTIKUM:</a:t>
+              <a:t>💡 TIPS PRAKTIKUM &amp; PEDOMAN:</a:t>
             </a:r>
             <a:br/>
             <a:r>
-              <a:t>Selalu pasangkan wadah warna (primaryContainer) dengan teks pasangannya (onPrimaryContainer)!</a:t>
+              <a:t>Hukum Emas Kontras: Wadah 'xyzContainer' WAJIB dipasangkan dengan teks 'onXyzContainer'!</a:t>
             </a:r>
           </a:p>
         </p:txBody>
@@ -14242,7 +14250,7 @@
             </a:r>
             <a:br/>
             <a:r>
-              <a:t>  color: colors.primaryContainer,</a:t>
+              <a:t>  color: colors.primaryContainer, // Warna kotak kaus</a:t>
             </a:r>
             <a:br/>
             <a:r>
@@ -14254,7 +14262,7 @@
             </a:r>
             <a:br/>
             <a:r>
-              <a:t>    style: TextStyle(color: colors.onPrimaryContainer),</a:t>
+              <a:t>    style: TextStyle(color: colors.onPrimaryContainer), // Warna sablon</a:t>
             </a:r>
             <a:br/>
             <a:r>
@@ -14612,7 +14620,7 @@
               </a:defRPr>
             </a:pPr>
             <a:r>
-              <a:t>Skala Tipografi M3: Display, Headline, Title, Body</a:t>
+              <a:t>Skala Tipografi M3: Hirarki Koran &amp; Majalah (Anti-Hardcode)</a:t>
             </a:r>
           </a:p>
         </p:txBody>
@@ -14781,7 +14789,7 @@
               </a:defRPr>
             </a:pPr>
             <a:r>
-              <a:t>💡 KONSEP INTI &amp; CARA KERJA</a:t>
+              <a:t>💡 KONSEP INTI &amp; ANALOGI AWAM</a:t>
             </a:r>
           </a:p>
         </p:txBody>
@@ -14794,8 +14802,8 @@
         </p:nvSpPr>
         <p:spPr>
           <a:xfrm>
-            <a:off x="1005840" y="2176272"/>
-            <a:ext cx="4023360" cy="2926080"/>
+            <a:off x="1005840" y="2157984"/>
+            <a:ext cx="4023360" cy="2834640"/>
           </a:xfrm>
           <a:prstGeom prst="rect">
             <a:avLst/>
@@ -14810,9 +14818,9 @@
           <a:p>
             <a:pPr>
               <a:spcAft>
-                <a:spcPts val="800"/>
+                <a:spcPts val="600"/>
               </a:spcAft>
-              <a:defRPr sz="1050">
+              <a:defRPr sz="980">
                 <a:solidFill>
                   <a:srgbClr val="141414"/>
                 </a:solidFill>
@@ -14820,15 +14828,15 @@
               </a:defRPr>
             </a:pPr>
             <a:r>
-              <a:t>■  Hindari melakukan hardcode 'fontSize: 24' pada widget Text Anda!</a:t>
+              <a:t>■  📰 Analogi Koran &amp; Majalah: Desain punya susunan rapi—Display (baliho), Headline (judul bab), Title (judul kartu), Body (isi bacaan).</a:t>
             </a:r>
           </a:p>
           <a:p>
             <a:pPr>
               <a:spcAft>
-                <a:spcPts val="800"/>
+                <a:spcPts val="600"/>
               </a:spcAft>
-              <a:defRPr sz="1050">
+              <a:defRPr sz="980">
                 <a:solidFill>
                   <a:srgbClr val="141414"/>
                 </a:solidFill>
@@ -14836,15 +14844,15 @@
               </a:defRPr>
             </a:pPr>
             <a:r>
-              <a:t>■  Gunakan skala teks resmi Google: Display (sangat besar), Headline (judul bab), Title (judul kartu), Body (paragraf isi).</a:t>
+              <a:t>■  🚫 Dilarang Keras: Hindari menulis 'fontSize: 24' manual! Ukuran kaku membuat teks tidak fleksibel terhadap setelan HP pengguna.</a:t>
             </a:r>
           </a:p>
           <a:p>
             <a:pPr>
               <a:spcAft>
-                <a:spcPts val="800"/>
+                <a:spcPts val="600"/>
               </a:spcAft>
-              <a:defRPr sz="1050">
+              <a:defRPr sz="980">
                 <a:solidFill>
                   <a:srgbClr val="141414"/>
                 </a:solidFill>
@@ -14852,15 +14860,15 @@
               </a:defRPr>
             </a:pPr>
             <a:r>
-              <a:t>■  Standar default teks aplikasi adalah 'bodyMedium' (14sp).</a:t>
+              <a:t>■  👓 Peduli Lansia: Saat kakek/nenek memperbesar ukuran huruf sistem di HP (150%), 'TextTheme' otomatis menyesuaikan diri tanpa merusak mata.</a:t>
             </a:r>
           </a:p>
           <a:p>
             <a:pPr>
               <a:spcAft>
-                <a:spcPts val="800"/>
+                <a:spcPts val="600"/>
               </a:spcAft>
-              <a:defRPr sz="1050">
+              <a:defRPr sz="980">
                 <a:solidFill>
                   <a:srgbClr val="141414"/>
                 </a:solidFill>
@@ -14868,7 +14876,7 @@
               </a:defRPr>
             </a:pPr>
             <a:r>
-              <a:t>■  Keuntungan: Otomatis mematuhi pengaturan aksesibilitas pembesaran huruf di smartphone pengguna tunanetra.</a:t>
+              <a:t>■  📖 Standar Default: Standar paragraf utama aplikasi Flutter adalah 'bodyMedium' (14sp), nyaman dibaca di segala kerapatan layar.</a:t>
             </a:r>
           </a:p>
         </p:txBody>
@@ -14881,8 +14889,8 @@
         </p:nvSpPr>
         <p:spPr>
           <a:xfrm>
-            <a:off x="960120" y="5074920"/>
-            <a:ext cx="4114800" cy="1005840"/>
+            <a:off x="960120" y="5047488"/>
+            <a:ext cx="4114800" cy="1051560"/>
           </a:xfrm>
           <a:prstGeom prst="rect">
             <a:avLst/>
@@ -14926,8 +14934,8 @@
         </p:nvSpPr>
         <p:spPr>
           <a:xfrm>
-            <a:off x="1005840" y="5102352"/>
-            <a:ext cx="4023360" cy="914400"/>
+            <a:off x="1005840" y="5074920"/>
+            <a:ext cx="4023360" cy="960120"/>
           </a:xfrm>
           <a:prstGeom prst="rect">
             <a:avLst/>
@@ -14941,7 +14949,7 @@
           <a:lstStyle/>
           <a:p>
             <a:pPr>
-              <a:defRPr sz="950" b="1">
+              <a:defRPr sz="919" b="1">
                 <a:solidFill>
                   <a:srgbClr val="000000"/>
                 </a:solidFill>
@@ -14949,11 +14957,11 @@
               </a:defRPr>
             </a:pPr>
             <a:r>
-              <a:t>💡 TIPS PRAKTIKUM:</a:t>
+              <a:t>💡 TIPS PRAKTIKUM &amp; PEDOMAN:</a:t>
             </a:r>
             <a:br/>
             <a:r>
-              <a:t>Memanfaatkan TextTheme menjamin aplikasi Anda ramah aksesibilitas tunanetra!</a:t>
+              <a:t>Gunakan TextTheme agar aplikasi Anda otomatis mematuhi aksesibilitas pembesaran font!</a:t>
             </a:r>
           </a:p>
         </p:txBody>
@@ -15525,7 +15533,7 @@
               </a:defRPr>
             </a:pPr>
             <a:r>
-              <a:t>Mendukung Tema Terang &amp; Gelap (Light &amp; Dark)</a:t>
+              <a:t>Tema Dinamis: Kacamata Hitam Transitions (Light, Dark, System)</a:t>
             </a:r>
           </a:p>
         </p:txBody>
@@ -15694,7 +15702,7 @@
               </a:defRPr>
             </a:pPr>
             <a:r>
-              <a:t>💡 KONSEP INTI &amp; CARA KERJA</a:t>
+              <a:t>💡 KONSEP INTI &amp; ANALOGI AWAM</a:t>
             </a:r>
           </a:p>
         </p:txBody>
@@ -15707,8 +15715,8 @@
         </p:nvSpPr>
         <p:spPr>
           <a:xfrm>
-            <a:off x="1005840" y="2176272"/>
-            <a:ext cx="4023360" cy="2926080"/>
+            <a:off x="1005840" y="2157984"/>
+            <a:ext cx="4023360" cy="2834640"/>
           </a:xfrm>
           <a:prstGeom prst="rect">
             <a:avLst/>
@@ -15723,9 +15731,9 @@
           <a:p>
             <a:pPr>
               <a:spcAft>
-                <a:spcPts val="800"/>
+                <a:spcPts val="600"/>
               </a:spcAft>
-              <a:defRPr sz="1050">
+              <a:defRPr sz="980">
                 <a:solidFill>
                   <a:srgbClr val="141414"/>
                 </a:solidFill>
@@ -15733,15 +15741,15 @@
               </a:defRPr>
             </a:pPr>
             <a:r>
-              <a:t>■  Aplikasi modern wajib mendukung mode gelap demi kenyamanan mata dan efisiensi baterai layar OLED.</a:t>
+              <a:t>■  🕶️ Analogi Lensa Transitions: Bening saat di dalam ruangan, otomatis gelap sejuk saat di luar terik matahari. Begitu pula tema terang dan gelap.</a:t>
             </a:r>
           </a:p>
           <a:p>
             <a:pPr>
               <a:spcAft>
-                <a:spcPts val="800"/>
+                <a:spcPts val="600"/>
               </a:spcAft>
-              <a:defRPr sz="1050">
+              <a:defRPr sz="980">
                 <a:solidFill>
                   <a:srgbClr val="141414"/>
                 </a:solidFill>
@@ -15749,15 +15757,15 @@
               </a:defRPr>
             </a:pPr>
             <a:r>
-              <a:t>■  MaterialApp memiliki 3 properti kunci: 'theme' (terang), 'darkTheme' (gelap), dan 'themeMode'.</a:t>
+              <a:t>■  🌙 Manfaat Mode Gelap: Mengistirahatkan mata pengguna di malam hari dan menghemat baterai layar OLED/AMOLED smartphone secara signifikan.</a:t>
             </a:r>
           </a:p>
           <a:p>
             <a:pPr>
               <a:spcAft>
-                <a:spcPts val="800"/>
+                <a:spcPts val="600"/>
               </a:spcAft>
-              <a:defRPr sz="1050">
+              <a:defRPr sz="980">
                 <a:solidFill>
                   <a:srgbClr val="141414"/>
                 </a:solidFill>
@@ -15765,15 +15773,15 @@
               </a:defRPr>
             </a:pPr>
             <a:r>
-              <a:t>■  'ThemeMode.system' akan otomatis mengikuti setelan tema di sistem operasi HP pengguna.</a:t>
+              <a:t>■  ⚙️ Tiga Pasak Utama: MaterialApp memiliki properti 'theme' (terang), 'darkTheme' (gelap), dan pengatur saklar 'themeMode'.</a:t>
             </a:r>
           </a:p>
           <a:p>
             <a:pPr>
               <a:spcAft>
-                <a:spcPts val="800"/>
+                <a:spcPts val="600"/>
               </a:spcAft>
-              <a:defRPr sz="1050">
+              <a:defRPr sz="980">
                 <a:solidFill>
                   <a:srgbClr val="141414"/>
                 </a:solidFill>
@@ -15781,7 +15789,7 @@
               </a:defRPr>
             </a:pPr>
             <a:r>
-              <a:t>■  Uji kontras teks Anda pada kedua mode sebelum mengumpulkan tugas praktikum.</a:t>
+              <a:t>■  🔄 Ikut Setelan HP: 'ThemeMode.system' akan otomatis mendeteksi apakah smartphone pengguna sedang mode gelap tanpa perlu tombol manual.</a:t>
             </a:r>
           </a:p>
         </p:txBody>
@@ -15794,8 +15802,8 @@
         </p:nvSpPr>
         <p:spPr>
           <a:xfrm>
-            <a:off x="960120" y="5074920"/>
-            <a:ext cx="4114800" cy="1005840"/>
+            <a:off x="960120" y="5047488"/>
+            <a:ext cx="4114800" cy="1051560"/>
           </a:xfrm>
           <a:prstGeom prst="rect">
             <a:avLst/>
@@ -15839,8 +15847,8 @@
         </p:nvSpPr>
         <p:spPr>
           <a:xfrm>
-            <a:off x="1005840" y="5102352"/>
-            <a:ext cx="4023360" cy="914400"/>
+            <a:off x="1005840" y="5074920"/>
+            <a:ext cx="4023360" cy="960120"/>
           </a:xfrm>
           <a:prstGeom prst="rect">
             <a:avLst/>
@@ -15854,7 +15862,7 @@
           <a:lstStyle/>
           <a:p>
             <a:pPr>
-              <a:defRPr sz="950" b="1">
+              <a:defRPr sz="919" b="1">
                 <a:solidFill>
                   <a:srgbClr val="000000"/>
                 </a:solidFill>
@@ -15862,11 +15870,11 @@
               </a:defRPr>
             </a:pPr>
             <a:r>
-              <a:t>💡 TIPS PRAKTIKUM:</a:t>
+              <a:t>💡 TIPS PRAKTIKUM &amp; PEDOMAN:</a:t>
             </a:r>
             <a:br/>
             <a:r>
-              <a:t>Gunakan SegmentedButton untuk memberikan opsi ganti tema Terang/Gelap/Sistem.</a:t>
+              <a:t>Gunakan SegmentedButton untuk memberi opsi ganti tema Terang, Gelap, atau Ikut Sistem!</a:t>
             </a:r>
           </a:p>
         </p:txBody>
@@ -16087,7 +16095,7 @@
             </a:r>
             <a:br/>
             <a:r>
-              <a:t>    brightness: Brightness.light,</a:t>
+              <a:t>    brightness: Brightness.light, // Terang</a:t>
             </a:r>
             <a:br/>
             <a:r>
@@ -16107,7 +16115,7 @@
             </a:r>
             <a:br/>
             <a:r>
-              <a:t>    brightness: Brightness.dark,</a:t>
+              <a:t>    brightness: Brightness.dark,  // Gelap</a:t>
             </a:r>
             <a:br/>
             <a:r>
@@ -16469,7 +16477,7 @@
               </a:defRPr>
             </a:pPr>
             <a:r>
-              <a:t>MediaQuery: Membaca Ukuran Layar Fisik Total</a:t>
+              <a:t>MediaQuery: Sertifikat Luas Tanah Seluruh Layar HP</a:t>
             </a:r>
           </a:p>
         </p:txBody>
@@ -16638,7 +16646,7 @@
               </a:defRPr>
             </a:pPr>
             <a:r>
-              <a:t>💡 KONSEP INTI &amp; CARA KERJA</a:t>
+              <a:t>💡 KONSEP INTI &amp; ANALOGI AWAM</a:t>
             </a:r>
           </a:p>
         </p:txBody>
@@ -16651,8 +16659,8 @@
         </p:nvSpPr>
         <p:spPr>
           <a:xfrm>
-            <a:off x="1005840" y="2176272"/>
-            <a:ext cx="4023360" cy="2926080"/>
+            <a:off x="1005840" y="2157984"/>
+            <a:ext cx="4023360" cy="2834640"/>
           </a:xfrm>
           <a:prstGeom prst="rect">
             <a:avLst/>
@@ -16667,9 +16675,9 @@
           <a:p>
             <a:pPr>
               <a:spcAft>
-                <a:spcPts val="800"/>
+                <a:spcPts val="600"/>
               </a:spcAft>
-              <a:defRPr sz="1050">
+              <a:defRPr sz="980">
                 <a:solidFill>
                   <a:srgbClr val="141414"/>
                 </a:solidFill>
@@ -16677,15 +16685,15 @@
               </a:defRPr>
             </a:pPr>
             <a:r>
-              <a:t>■  MediaQuery memberikan informasi menyeluruh tentang perangkat fisik tempat aplikasi berjalan.</a:t>
+              <a:t>■  📐 Analogi Luas Tanah Rumah: MediaQuery mengukur luas total seluruh bentang kaca layar HP dari ujung kiri atas ke kanan bawah.</a:t>
             </a:r>
           </a:p>
           <a:p>
             <a:pPr>
               <a:spcAft>
-                <a:spcPts val="800"/>
+                <a:spcPts val="600"/>
               </a:spcAft>
-              <a:defRPr sz="1050">
+              <a:defRPr sz="980">
                 <a:solidFill>
                   <a:srgbClr val="141414"/>
                 </a:solidFill>
@@ -16693,15 +16701,15 @@
               </a:defRPr>
             </a:pPr>
             <a:r>
-              <a:t>■  Membaca dimensi: 'MediaQuery.sizeOf(context).width' dan '.height'.</a:t>
+              <a:t>■  📏 Membaca Dimensi: 'MediaQuery.sizeOf(context).width' dan '.height' mengembalikan lebar &amp; tinggi total dalam satuan dp.</a:t>
             </a:r>
           </a:p>
           <a:p>
             <a:pPr>
               <a:spcAft>
-                <a:spcPts val="800"/>
+                <a:spcPts val="600"/>
               </a:spcAft>
-              <a:defRPr sz="1050">
+              <a:defRPr sz="980">
                 <a:solidFill>
                   <a:srgbClr val="141414"/>
                 </a:solidFill>
@@ -16709,15 +16717,15 @@
               </a:defRPr>
             </a:pPr>
             <a:r>
-              <a:t>■  Membaca orientasi: 'MediaQuery.orientationOf(context) == Orientation.portrait'.</a:t>
+              <a:t>■  📱 Deteksi Poni &amp; Keyboard: MediaQuery juga mengetahui area terpotong kamera depan (Safe Area / paddingOf) dan munculnya keyboard.</a:t>
             </a:r>
           </a:p>
           <a:p>
             <a:pPr>
               <a:spcAft>
-                <a:spcPts val="800"/>
+                <a:spcPts val="600"/>
               </a:spcAft>
-              <a:defRPr sz="1050">
+              <a:defRPr sz="980">
                 <a:solidFill>
                   <a:srgbClr val="141414"/>
                 </a:solidFill>
@@ -16725,7 +16733,7 @@
               </a:defRPr>
             </a:pPr>
             <a:r>
-              <a:t>■  ⚠️ Catatan Awam: MediaQuery mengukur SELURUH layar HP, bukan ruang sempit di dalam dialog atau split-view.</a:t>
+              <a:t>■  ⚠️ Batasan: MediaQuery mengukur SELURUH layar fisik, bukan ruang sempit di dalam kartu atau dialog pop-up split-view.</a:t>
             </a:r>
           </a:p>
         </p:txBody>
@@ -16738,8 +16746,8 @@
         </p:nvSpPr>
         <p:spPr>
           <a:xfrm>
-            <a:off x="960120" y="5074920"/>
-            <a:ext cx="4114800" cy="1005840"/>
+            <a:off x="960120" y="5047488"/>
+            <a:ext cx="4114800" cy="1051560"/>
           </a:xfrm>
           <a:prstGeom prst="rect">
             <a:avLst/>
@@ -16783,8 +16791,8 @@
         </p:nvSpPr>
         <p:spPr>
           <a:xfrm>
-            <a:off x="1005840" y="5102352"/>
-            <a:ext cx="4023360" cy="914400"/>
+            <a:off x="1005840" y="5074920"/>
+            <a:ext cx="4023360" cy="960120"/>
           </a:xfrm>
           <a:prstGeom prst="rect">
             <a:avLst/>
@@ -16798,7 +16806,7 @@
           <a:lstStyle/>
           <a:p>
             <a:pPr>
-              <a:defRPr sz="950" b="1">
+              <a:defRPr sz="919" b="1">
                 <a:solidFill>
                   <a:srgbClr val="000000"/>
                 </a:solidFill>
@@ -16806,11 +16814,11 @@
               </a:defRPr>
             </a:pPr>
             <a:r>
-              <a:t>💡 TIPS PRAKTIKUM:</a:t>
+              <a:t>💡 TIPS PRAKTIKUM &amp; PEDOMAN:</a:t>
             </a:r>
             <a:br/>
             <a:r>
-              <a:t>Gunakan MediaQuery.sizeOf(context) daripada MediaQuery.of(context).size untuk efisiensi rebuild!</a:t>
+              <a:t>Gunakan MediaQuery.sizeOf(context) alih-alih MediaQuery.of(context).size untuk efisiensi rebuild!</a:t>
             </a:r>
           </a:p>
         </p:txBody>
@@ -17024,7 +17032,7 @@
             <a:br/>
             <a:br/>
             <a:r>
-              <a:t>// Deteksi orientasi:</a:t>
+              <a:t>// Deteksi orientasi tegak vs miring:</a:t>
             </a:r>
             <a:br/>
             <a:r>
@@ -17037,7 +17045,7 @@
             <a:br/>
             <a:br/>
             <a:r>
-              <a:t>print('Lebar Layar: ${size.width} dp');</a:t>
+              <a:t>print('Lebar Layar Total: ${size.width} dp');</a:t>
             </a:r>
           </a:p>
         </p:txBody>
@@ -17387,7 +17395,7 @@
               </a:defRPr>
             </a:pPr>
             <a:r>
-              <a:t>LayoutBuilder: Mengetahui Ruang Tersedia dari Parent</a:t>
+              <a:t>LayoutBuilder: Ruang Kosong Sudut Kamar untuk Lemari</a:t>
             </a:r>
           </a:p>
         </p:txBody>
@@ -17556,7 +17564,7 @@
               </a:defRPr>
             </a:pPr>
             <a:r>
-              <a:t>💡 KONSEP INTI &amp; CARA KERJA</a:t>
+              <a:t>💡 KONSEP INTI &amp; ANALOGI AWAM</a:t>
             </a:r>
           </a:p>
         </p:txBody>
@@ -17569,8 +17577,8 @@
         </p:nvSpPr>
         <p:spPr>
           <a:xfrm>
-            <a:off x="1005840" y="2176272"/>
-            <a:ext cx="4023360" cy="2926080"/>
+            <a:off x="1005840" y="2157984"/>
+            <a:ext cx="4023360" cy="2834640"/>
           </a:xfrm>
           <a:prstGeom prst="rect">
             <a:avLst/>
@@ -17585,9 +17593,9 @@
           <a:p>
             <a:pPr>
               <a:spcAft>
-                <a:spcPts val="800"/>
+                <a:spcPts val="600"/>
               </a:spcAft>
-              <a:defRPr sz="1050">
+              <a:defRPr sz="980">
                 <a:solidFill>
                   <a:srgbClr val="141414"/>
                 </a:solidFill>
@@ -17595,15 +17603,15 @@
               </a:defRPr>
             </a:pPr>
             <a:r>
-              <a:t>■  Inilah senjata rahasia membangun komponen antarmuka yang benar-benar modular dan fleksibel.</a:t>
+              <a:t>■  🚪 Analogi Lemari Sudut Kamar: Lemari tidak peduli luas seluruh rumah (MediaQuery), yang penting berapa ruang kosong di sudut kamar!</a:t>
             </a:r>
           </a:p>
           <a:p>
             <a:pPr>
               <a:spcAft>
-                <a:spcPts val="800"/>
+                <a:spcPts val="600"/>
               </a:spcAft>
-              <a:defRPr sz="1050">
+              <a:defRPr sz="980">
                 <a:solidFill>
                   <a:srgbClr val="141414"/>
                 </a:solidFill>
@@ -17611,15 +17619,15 @@
               </a:defRPr>
             </a:pPr>
             <a:r>
-              <a:t>■  LayoutBuilder menyediakan objek 'BoxConstraints': memberi tahu lebar maksimum yang boleh digunakan widget anak.</a:t>
+              <a:t>■  📦 BoxConstraints: LayoutBuilder memberikan 'constraints.maxWidth'—lebar maksimum yang disiapkan oleh widget induk (*parent*).</a:t>
             </a:r>
           </a:p>
           <a:p>
             <a:pPr>
               <a:spcAft>
-                <a:spcPts val="800"/>
+                <a:spcPts val="600"/>
               </a:spcAft>
-              <a:defRPr sz="1050">
+              <a:defRPr sz="980">
                 <a:solidFill>
                   <a:srgbClr val="141414"/>
                 </a:solidFill>
@@ -17627,15 +17635,15 @@
               </a:defRPr>
             </a:pPr>
             <a:r>
-              <a:t>■  Sangat ideal untuk kartu yang bisa tampil di ponsel penuh (lebar 400dp) maupun di dalam tablet split-view (lebar 300dp).</a:t>
+              <a:t>■  🧩 Senjata Komponen Modular: Satu kartu yang sama bisa otomatis tampil vertikal (Column) jika sempit, atau horizontal (Row) jika lapang.</a:t>
             </a:r>
           </a:p>
           <a:p>
             <a:pPr>
               <a:spcAft>
-                <a:spcPts val="800"/>
+                <a:spcPts val="600"/>
               </a:spcAft>
-              <a:defRPr sz="1050">
+              <a:defRPr sz="980">
                 <a:solidFill>
                   <a:srgbClr val="141414"/>
                 </a:solidFill>
@@ -17643,7 +17651,7 @@
               </a:defRPr>
             </a:pPr>
             <a:r>
-              <a:t>■  Hukum Emas: Jika membuat widget modular, gunakan LayoutBuilder, BUKAN MediaQuery!</a:t>
+              <a:t>■  👑 Hukum Emas Widget: Jika Anda membangun widget modular/reusable, selalu gunakan LayoutBuilder, BUKAN MediaQuery!</a:t>
             </a:r>
           </a:p>
         </p:txBody>
@@ -17656,8 +17664,8 @@
         </p:nvSpPr>
         <p:spPr>
           <a:xfrm>
-            <a:off x="960120" y="5074920"/>
-            <a:ext cx="4114800" cy="1005840"/>
+            <a:off x="960120" y="5047488"/>
+            <a:ext cx="4114800" cy="1051560"/>
           </a:xfrm>
           <a:prstGeom prst="rect">
             <a:avLst/>
@@ -17701,8 +17709,8 @@
         </p:nvSpPr>
         <p:spPr>
           <a:xfrm>
-            <a:off x="1005840" y="5102352"/>
-            <a:ext cx="4023360" cy="914400"/>
+            <a:off x="1005840" y="5074920"/>
+            <a:ext cx="4023360" cy="960120"/>
           </a:xfrm>
           <a:prstGeom prst="rect">
             <a:avLst/>
@@ -17716,7 +17724,7 @@
           <a:lstStyle/>
           <a:p>
             <a:pPr>
-              <a:defRPr sz="950" b="1">
+              <a:defRPr sz="919" b="1">
                 <a:solidFill>
                   <a:srgbClr val="000000"/>
                 </a:solidFill>
@@ -17724,11 +17732,11 @@
               </a:defRPr>
             </a:pPr>
             <a:r>
-              <a:t>💡 TIPS PRAKTIKUM:</a:t>
+              <a:t>💡 TIPS PRAKTIKUM &amp; PEDOMAN:</a:t>
             </a:r>
             <a:br/>
             <a:r>
-              <a:t>LayoutBuilder memungkinkan satu widget yang sama tampil rapi di HP, tablet, maupun dialog pop-up!</a:t>
+              <a:t>LayoutBuilder membuat widget Anda fleksibel tampil di HP penuh, tablet split-pane, maupun pop-up!</a:t>
             </a:r>
           </a:p>
         </p:txBody>
@@ -17938,6 +17946,10 @@
             <a:br/>
             <a:r>
               <a:t>  builder: (context, constraints) {</a:t>
+            </a:r>
+            <a:br/>
+            <a:r>
+              <a:t>    // Membaca ruang yang diizinkan oleh parent:</a:t>
             </a:r>
             <a:br/>
             <a:r>
@@ -18315,7 +18327,7 @@
               </a:defRPr>
             </a:pPr>
             <a:r>
-              <a:t>Standar Ambang Layar Google (Compact, Medium, Expanded)</a:t>
+              <a:t>Standar Breakpoints Google: Ukuran Baju S, M, L Layar Digital</a:t>
             </a:r>
           </a:p>
         </p:txBody>
@@ -18484,7 +18496,7 @@
               </a:defRPr>
             </a:pPr>
             <a:r>
-              <a:t>💡 KONSEP INTI &amp; CARA KERJA</a:t>
+              <a:t>💡 KONSEP INTI &amp; ANALOGI AWAM</a:t>
             </a:r>
           </a:p>
         </p:txBody>
@@ -18497,8 +18509,8 @@
         </p:nvSpPr>
         <p:spPr>
           <a:xfrm>
-            <a:off x="1005840" y="2176272"/>
-            <a:ext cx="4023360" cy="2926080"/>
+            <a:off x="1005840" y="2157984"/>
+            <a:ext cx="4023360" cy="2834640"/>
           </a:xfrm>
           <a:prstGeom prst="rect">
             <a:avLst/>
@@ -18513,9 +18525,9 @@
           <a:p>
             <a:pPr>
               <a:spcAft>
-                <a:spcPts val="800"/>
+                <a:spcPts val="600"/>
               </a:spcAft>
-              <a:defRPr sz="1050">
+              <a:defRPr sz="980">
                 <a:solidFill>
                   <a:srgbClr val="141414"/>
                 </a:solidFill>
@@ -18523,15 +18535,15 @@
               </a:defRPr>
             </a:pPr>
             <a:r>
-              <a:t>■  Compact (&lt; 600 dp): Mayoritas smartphone dalam posisi tegak (portrait). Tata letak 1 kolom.</a:t>
+              <a:t>■  👕 Analogi Ukuran Baju: Tubuh punya ukuran baju S, M, L. Layar digital pun memiliki 3 klasifikasi standar industri resmi Google:</a:t>
             </a:r>
           </a:p>
           <a:p>
             <a:pPr>
               <a:spcAft>
-                <a:spcPts val="800"/>
+                <a:spcPts val="600"/>
               </a:spcAft>
-              <a:defRPr sz="1050">
+              <a:defRPr sz="980">
                 <a:solidFill>
                   <a:srgbClr val="141414"/>
                 </a:solidFill>
@@ -18539,15 +18551,15 @@
               </a:defRPr>
             </a:pPr>
             <a:r>
-              <a:t>■  Medium (600 dp s.d. 840 dp): Tablet kecil, ponsel lipat terbuka (*foldable*), atau ponsel miring (landscape).</a:t>
+              <a:t>■  📱 S - Compact (&lt; 600 dp): Mayoritas smartphone posisi tegak (*portrait*). Tata letak 1 kolom sederhana.</a:t>
             </a:r>
           </a:p>
           <a:p>
             <a:pPr>
               <a:spcAft>
-                <a:spcPts val="800"/>
+                <a:spcPts val="600"/>
               </a:spcAft>
-              <a:defRPr sz="1050">
+              <a:defRPr sz="980">
                 <a:solidFill>
                   <a:srgbClr val="141414"/>
                 </a:solidFill>
@@ -18555,15 +18567,15 @@
               </a:defRPr>
             </a:pPr>
             <a:r>
-              <a:t>■  Expanded (&gt; 840 dp): Tablet besar, laptop, dan layar monitor desktop. Tata letak multi-kolom.</a:t>
+              <a:t>■  📖 M - Medium (600 s.d. 840 dp): Tablet kecil, HP lipat (*foldable*), atau HP miring (*landscape*). Tata letak 2 kolom.</a:t>
             </a:r>
           </a:p>
           <a:p>
             <a:pPr>
               <a:spcAft>
-                <a:spcPts val="800"/>
+                <a:spcPts val="600"/>
               </a:spcAft>
-              <a:defRPr sz="1050">
+              <a:defRPr sz="980">
                 <a:solidFill>
                   <a:srgbClr val="141414"/>
                 </a:solidFill>
@@ -18571,7 +18583,7 @@
               </a:defRPr>
             </a:pPr>
             <a:r>
-              <a:t>■  Gunakan enum atau helper class sederhana untuk mengklasifikasikan tampilan aplikasi Anda.</a:t>
+              <a:t>■  🖥️ L - Expanded (&gt; 840 dp): Tablet besar, laptop, dan monitor desktop. Tata letak multi-kolom berdampingan.</a:t>
             </a:r>
           </a:p>
         </p:txBody>
@@ -18584,8 +18596,8 @@
         </p:nvSpPr>
         <p:spPr>
           <a:xfrm>
-            <a:off x="960120" y="5074920"/>
-            <a:ext cx="4114800" cy="1005840"/>
+            <a:off x="960120" y="5047488"/>
+            <a:ext cx="4114800" cy="1051560"/>
           </a:xfrm>
           <a:prstGeom prst="rect">
             <a:avLst/>
@@ -18629,8 +18641,8 @@
         </p:nvSpPr>
         <p:spPr>
           <a:xfrm>
-            <a:off x="1005840" y="5102352"/>
-            <a:ext cx="4023360" cy="914400"/>
+            <a:off x="1005840" y="5074920"/>
+            <a:ext cx="4023360" cy="960120"/>
           </a:xfrm>
           <a:prstGeom prst="rect">
             <a:avLst/>
@@ -18644,7 +18656,7 @@
           <a:lstStyle/>
           <a:p>
             <a:pPr>
-              <a:defRPr sz="950" b="1">
+              <a:defRPr sz="919" b="1">
                 <a:solidFill>
                   <a:srgbClr val="000000"/>
                 </a:solidFill>
@@ -18652,11 +18664,11 @@
               </a:defRPr>
             </a:pPr>
             <a:r>
-              <a:t>💡 TIPS PRAKTIKUM:</a:t>
+              <a:t>💡 TIPS PRAKTIKUM &amp; PEDOMAN:</a:t>
             </a:r>
             <a:br/>
             <a:r>
-              <a:t>Angka sakti yang wajib Anda hafal: 600 dp adalah batas antara Ponsel dan Tablet!</a:t>
+              <a:t>Angka sakti yang wajib Anda hafal: 600 dp adalah batas sakral antara Ponsel dan Tablet!</a:t>
             </a:r>
           </a:p>
         </p:txBody>
@@ -18870,15 +18882,15 @@
             </a:r>
             <a:br/>
             <a:r>
-              <a:t>  if (width &lt; 600) return WindowSize.compact;</a:t>
+              <a:t>  if (width &lt; 600) return WindowSize.compact;  // Ukuran S (HP)</a:t>
             </a:r>
             <a:br/>
             <a:r>
-              <a:t>  if (width &lt; 840) return WindowSize.medium;</a:t>
+              <a:t>  if (width &lt; 840) return WindowSize.medium;   // Ukuran M (Tablet)</a:t>
             </a:r>
             <a:br/>
             <a:r>
-              <a:t>  return WindowSize.expanded;</a:t>
+              <a:t>  return WindowSize.expanded;                  // Ukuran L (Desktop)</a:t>
             </a:r>
             <a:br/>
             <a:r>

</xml_diff>